<commit_message>
Update Lecture 11a opening framing slides
</commit_message>
<xml_diff>
--- a/files/inst414_spring2026/lectures/lecture_11a_fairness_metrics_compas.pptx
+++ b/files/inst414_spring2026/lectures/lecture_11a_fairness_metrics_compas.pptx
@@ -5,36 +5,40 @@
     <p:sldMasterId id="2147483648" r:id="rId1"/>
   </p:sldMasterIdLst>
   <p:notesMasterIdLst>
-    <p:notesMasterId r:id="rId29"/>
+    <p:notesMasterId r:id="rId33"/>
   </p:notesMasterIdLst>
   <p:sldIdLst>
     <p:sldId id="264" r:id="rId2"/>
-    <p:sldId id="669" r:id="rId3"/>
-    <p:sldId id="765" r:id="rId4"/>
-    <p:sldId id="679" r:id="rId5"/>
-    <p:sldId id="764" r:id="rId6"/>
-    <p:sldId id="298" r:id="rId7"/>
-    <p:sldId id="434" r:id="rId8"/>
-    <p:sldId id="727" r:id="rId9"/>
-    <p:sldId id="435" r:id="rId10"/>
-    <p:sldId id="436" r:id="rId11"/>
-    <p:sldId id="758" r:id="rId12"/>
-    <p:sldId id="437" r:id="rId13"/>
-    <p:sldId id="438" r:id="rId14"/>
-    <p:sldId id="760" r:id="rId15"/>
-    <p:sldId id="386" r:id="rId16"/>
-    <p:sldId id="387" r:id="rId17"/>
-    <p:sldId id="688" r:id="rId18"/>
-    <p:sldId id="294" r:id="rId19"/>
-    <p:sldId id="761" r:id="rId20"/>
-    <p:sldId id="647" r:id="rId21"/>
-    <p:sldId id="268" r:id="rId22"/>
-    <p:sldId id="648" r:id="rId23"/>
-    <p:sldId id="271" r:id="rId24"/>
-    <p:sldId id="649" r:id="rId25"/>
-    <p:sldId id="650" r:id="rId26"/>
-    <p:sldId id="273" r:id="rId27"/>
-    <p:sldId id="766" r:id="rId28"/>
+    <p:sldId id="767" r:id="rId3"/>
+    <p:sldId id="768" r:id="rId4"/>
+    <p:sldId id="769" r:id="rId5"/>
+    <p:sldId id="770" r:id="rId6"/>
+    <p:sldId id="669" r:id="rId7"/>
+    <p:sldId id="765" r:id="rId8"/>
+    <p:sldId id="679" r:id="rId9"/>
+    <p:sldId id="764" r:id="rId10"/>
+    <p:sldId id="298" r:id="rId11"/>
+    <p:sldId id="434" r:id="rId12"/>
+    <p:sldId id="727" r:id="rId13"/>
+    <p:sldId id="435" r:id="rId14"/>
+    <p:sldId id="436" r:id="rId15"/>
+    <p:sldId id="758" r:id="rId16"/>
+    <p:sldId id="437" r:id="rId17"/>
+    <p:sldId id="438" r:id="rId18"/>
+    <p:sldId id="760" r:id="rId19"/>
+    <p:sldId id="386" r:id="rId20"/>
+    <p:sldId id="387" r:id="rId21"/>
+    <p:sldId id="688" r:id="rId22"/>
+    <p:sldId id="294" r:id="rId23"/>
+    <p:sldId id="761" r:id="rId24"/>
+    <p:sldId id="647" r:id="rId25"/>
+    <p:sldId id="268" r:id="rId26"/>
+    <p:sldId id="648" r:id="rId27"/>
+    <p:sldId id="271" r:id="rId28"/>
+    <p:sldId id="649" r:id="rId29"/>
+    <p:sldId id="650" r:id="rId30"/>
+    <p:sldId id="273" r:id="rId31"/>
+    <p:sldId id="766" r:id="rId32"/>
   </p:sldIdLst>
   <p:sldSz cx="12192000" cy="6858000"/>
   <p:notesSz cx="6858000" cy="9144000"/>
@@ -223,7 +227,7 @@
           <a:p>
             <a:fld id="{AFA8005B-BB1C-4B9D-A8C4-F9CE1FCAFC3D}" type="datetimeFigureOut">
               <a:rPr lang="en-US" smtClean="0"/>
-              <a:t>4/14/2026</a:t>
+              <a:t>4/15/2026</a:t>
             </a:fld>
             <a:endParaRPr lang="en-US"/>
           </a:p>
@@ -514,6 +518,278 @@
             <a:spLocks noGrp="1" noRot="1" noChangeAspect="1"/>
           </p:cNvSpPr>
           <p:nvPr>
+            <p:ph type="sldImg" idx="2"/>
+          </p:nvPr>
+        </p:nvSpPr>
+        <p:spPr/>
+      </p:sp>
+      <p:sp>
+        <p:nvSpPr>
+          <p:cNvPr id="3" name="Notes Placeholder 2"/>
+          <p:cNvSpPr>
+            <a:spLocks noGrp="1"/>
+          </p:cNvSpPr>
+          <p:nvPr>
+            <p:ph type="body" sz="quarter" idx="3"/>
+          </p:nvPr>
+        </p:nvSpPr>
+        <p:spPr/>
+        <p:txBody>
+          <a:bodyPr/>
+          <a:lstStyle/>
+          <a:p>
+            <a:endParaRPr dirty="0"/>
+          </a:p>
+        </p:txBody>
+      </p:sp>
+      <p:sp>
+        <p:nvSpPr>
+          <p:cNvPr id="4" name="Slide Number Placeholder 3"/>
+          <p:cNvSpPr>
+            <a:spLocks noGrp="1"/>
+          </p:cNvSpPr>
+          <p:nvPr>
+            <p:ph type="sldNum" sz="quarter" idx="5"/>
+          </p:nvPr>
+        </p:nvSpPr>
+        <p:spPr/>
+      </p:sp>
+    </p:spTree>
+  </p:cSld>
+  <p:clrMapOvr>
+    <a:masterClrMapping/>
+  </p:clrMapOvr>
+</p:notes>
+</file>
+
+<file path=ppt/notesSlides/notesSlide2.xml><?xml version="1.0" encoding="utf-8"?>
+<p:notes xmlns:a="http://schemas.openxmlformats.org/drawingml/2006/main" xmlns:r="http://schemas.openxmlformats.org/officeDocument/2006/relationships" xmlns:p="http://schemas.openxmlformats.org/presentationml/2006/main">
+  <p:cSld>
+    <p:spTree>
+      <p:nvGrpSpPr>
+        <p:cNvPr id="1" name=""/>
+        <p:cNvGrpSpPr/>
+        <p:nvPr/>
+      </p:nvGrpSpPr>
+      <p:grpSpPr>
+        <a:xfrm>
+          <a:off x="0" y="0"/>
+          <a:ext cx="0" cy="0"/>
+          <a:chOff x="0" y="0"/>
+          <a:chExt cx="0" cy="0"/>
+        </a:xfrm>
+      </p:grpSpPr>
+      <p:sp>
+        <p:nvSpPr>
+          <p:cNvPr id="2" name="Slide Image Placeholder 1"/>
+          <p:cNvSpPr>
+            <a:spLocks noGrp="1" noRot="1" noChangeAspect="1"/>
+          </p:cNvSpPr>
+          <p:nvPr>
+            <p:ph type="sldImg" idx="2"/>
+          </p:nvPr>
+        </p:nvSpPr>
+        <p:spPr/>
+      </p:sp>
+      <p:sp>
+        <p:nvSpPr>
+          <p:cNvPr id="3" name="Notes Placeholder 2"/>
+          <p:cNvSpPr>
+            <a:spLocks noGrp="1"/>
+          </p:cNvSpPr>
+          <p:nvPr>
+            <p:ph type="body" sz="quarter" idx="3"/>
+          </p:nvPr>
+        </p:nvSpPr>
+        <p:spPr/>
+        <p:txBody>
+          <a:bodyPr/>
+          <a:lstStyle/>
+          <a:p>
+            <a:endParaRPr dirty="0"/>
+          </a:p>
+        </p:txBody>
+      </p:sp>
+      <p:sp>
+        <p:nvSpPr>
+          <p:cNvPr id="4" name="Slide Number Placeholder 3"/>
+          <p:cNvSpPr>
+            <a:spLocks noGrp="1"/>
+          </p:cNvSpPr>
+          <p:nvPr>
+            <p:ph type="sldNum" sz="quarter" idx="5"/>
+          </p:nvPr>
+        </p:nvSpPr>
+        <p:spPr/>
+      </p:sp>
+    </p:spTree>
+  </p:cSld>
+  <p:clrMapOvr>
+    <a:masterClrMapping/>
+  </p:clrMapOvr>
+</p:notes>
+</file>
+
+<file path=ppt/notesSlides/notesSlide3.xml><?xml version="1.0" encoding="utf-8"?>
+<p:notes xmlns:a="http://schemas.openxmlformats.org/drawingml/2006/main" xmlns:r="http://schemas.openxmlformats.org/officeDocument/2006/relationships" xmlns:p="http://schemas.openxmlformats.org/presentationml/2006/main">
+  <p:cSld>
+    <p:spTree>
+      <p:nvGrpSpPr>
+        <p:cNvPr id="1" name=""/>
+        <p:cNvGrpSpPr/>
+        <p:nvPr/>
+      </p:nvGrpSpPr>
+      <p:grpSpPr>
+        <a:xfrm>
+          <a:off x="0" y="0"/>
+          <a:ext cx="0" cy="0"/>
+          <a:chOff x="0" y="0"/>
+          <a:chExt cx="0" cy="0"/>
+        </a:xfrm>
+      </p:grpSpPr>
+      <p:sp>
+        <p:nvSpPr>
+          <p:cNvPr id="2" name="Slide Image Placeholder 1"/>
+          <p:cNvSpPr>
+            <a:spLocks noGrp="1" noRot="1" noChangeAspect="1"/>
+          </p:cNvSpPr>
+          <p:nvPr>
+            <p:ph type="sldImg" idx="2"/>
+          </p:nvPr>
+        </p:nvSpPr>
+        <p:spPr/>
+      </p:sp>
+      <p:sp>
+        <p:nvSpPr>
+          <p:cNvPr id="3" name="Notes Placeholder 2"/>
+          <p:cNvSpPr>
+            <a:spLocks noGrp="1"/>
+          </p:cNvSpPr>
+          <p:nvPr>
+            <p:ph type="body" sz="quarter" idx="3"/>
+          </p:nvPr>
+        </p:nvSpPr>
+        <p:spPr/>
+        <p:txBody>
+          <a:bodyPr/>
+          <a:lstStyle/>
+          <a:p>
+            <a:endParaRPr dirty="0"/>
+          </a:p>
+        </p:txBody>
+      </p:sp>
+      <p:sp>
+        <p:nvSpPr>
+          <p:cNvPr id="4" name="Slide Number Placeholder 3"/>
+          <p:cNvSpPr>
+            <a:spLocks noGrp="1"/>
+          </p:cNvSpPr>
+          <p:nvPr>
+            <p:ph type="sldNum" sz="quarter" idx="5"/>
+          </p:nvPr>
+        </p:nvSpPr>
+        <p:spPr/>
+      </p:sp>
+    </p:spTree>
+  </p:cSld>
+  <p:clrMapOvr>
+    <a:masterClrMapping/>
+  </p:clrMapOvr>
+</p:notes>
+</file>
+
+<file path=ppt/notesSlides/notesSlide4.xml><?xml version="1.0" encoding="utf-8"?>
+<p:notes xmlns:a="http://schemas.openxmlformats.org/drawingml/2006/main" xmlns:r="http://schemas.openxmlformats.org/officeDocument/2006/relationships" xmlns:p="http://schemas.openxmlformats.org/presentationml/2006/main">
+  <p:cSld>
+    <p:spTree>
+      <p:nvGrpSpPr>
+        <p:cNvPr id="1" name=""/>
+        <p:cNvGrpSpPr/>
+        <p:nvPr/>
+      </p:nvGrpSpPr>
+      <p:grpSpPr>
+        <a:xfrm>
+          <a:off x="0" y="0"/>
+          <a:ext cx="0" cy="0"/>
+          <a:chOff x="0" y="0"/>
+          <a:chExt cx="0" cy="0"/>
+        </a:xfrm>
+      </p:grpSpPr>
+      <p:sp>
+        <p:nvSpPr>
+          <p:cNvPr id="2" name="Slide Image Placeholder 1"/>
+          <p:cNvSpPr>
+            <a:spLocks noGrp="1" noRot="1" noChangeAspect="1"/>
+          </p:cNvSpPr>
+          <p:nvPr>
+            <p:ph type="sldImg" idx="2"/>
+          </p:nvPr>
+        </p:nvSpPr>
+        <p:spPr/>
+      </p:sp>
+      <p:sp>
+        <p:nvSpPr>
+          <p:cNvPr id="3" name="Notes Placeholder 2"/>
+          <p:cNvSpPr>
+            <a:spLocks noGrp="1"/>
+          </p:cNvSpPr>
+          <p:nvPr>
+            <p:ph type="body" sz="quarter" idx="3"/>
+          </p:nvPr>
+        </p:nvSpPr>
+        <p:spPr/>
+        <p:txBody>
+          <a:bodyPr/>
+          <a:lstStyle/>
+          <a:p>
+            <a:endParaRPr dirty="0"/>
+          </a:p>
+        </p:txBody>
+      </p:sp>
+      <p:sp>
+        <p:nvSpPr>
+          <p:cNvPr id="4" name="Slide Number Placeholder 3"/>
+          <p:cNvSpPr>
+            <a:spLocks noGrp="1"/>
+          </p:cNvSpPr>
+          <p:nvPr>
+            <p:ph type="sldNum" sz="quarter" idx="5"/>
+          </p:nvPr>
+        </p:nvSpPr>
+        <p:spPr/>
+      </p:sp>
+    </p:spTree>
+  </p:cSld>
+  <p:clrMapOvr>
+    <a:masterClrMapping/>
+  </p:clrMapOvr>
+</p:notes>
+</file>
+
+<file path=ppt/notesSlides/notesSlide5.xml><?xml version="1.0" encoding="utf-8"?>
+<p:notes xmlns:a="http://schemas.openxmlformats.org/drawingml/2006/main" xmlns:r="http://schemas.openxmlformats.org/officeDocument/2006/relationships" xmlns:p="http://schemas.openxmlformats.org/presentationml/2006/main">
+  <p:cSld>
+    <p:spTree>
+      <p:nvGrpSpPr>
+        <p:cNvPr id="1" name=""/>
+        <p:cNvGrpSpPr/>
+        <p:nvPr/>
+      </p:nvGrpSpPr>
+      <p:grpSpPr>
+        <a:xfrm>
+          <a:off x="0" y="0"/>
+          <a:ext cx="0" cy="0"/>
+          <a:chOff x="0" y="0"/>
+          <a:chExt cx="0" cy="0"/>
+        </a:xfrm>
+      </p:grpSpPr>
+      <p:sp>
+        <p:nvSpPr>
+          <p:cNvPr id="2" name="Slide Image Placeholder 1"/>
+          <p:cNvSpPr>
+            <a:spLocks noGrp="1" noRot="1" noChangeAspect="1"/>
+          </p:cNvSpPr>
+          <p:nvPr>
             <p:ph type="sldImg"/>
           </p:nvPr>
         </p:nvSpPr>
@@ -605,7 +881,7 @@
                 <a:tabLst/>
                 <a:defRPr/>
               </a:pPr>
-              <a:t>4</a:t>
+              <a:t>8</a:t>
             </a:fld>
             <a:endParaRPr kumimoji="0" lang="en-US" sz="1200" b="0" i="0" u="none" strike="noStrike" kern="1200" cap="none" spc="0" normalizeH="0" baseline="0" noProof="0">
               <a:ln>
@@ -637,7 +913,7 @@
 </p:notes>
 </file>
 
-<file path=ppt/notesSlides/notesSlide2.xml><?xml version="1.0" encoding="utf-8"?>
+<file path=ppt/notesSlides/notesSlide6.xml><?xml version="1.0" encoding="utf-8"?>
 <p:notes xmlns:a="http://schemas.openxmlformats.org/drawingml/2006/main" xmlns:r="http://schemas.openxmlformats.org/officeDocument/2006/relationships" xmlns:p="http://schemas.openxmlformats.org/presentationml/2006/main">
   <p:cSld>
     <p:spTree>
@@ -779,7 +1055,7 @@
                 <a:tabLst/>
                 <a:defRPr/>
               </a:pPr>
-              <a:t>19</a:t>
+              <a:t>23</a:t>
             </a:fld>
             <a:endParaRPr kumimoji="0" lang="en-US" sz="1200" b="0" i="0" u="none" strike="noStrike" kern="1200" cap="none" spc="0" normalizeH="0" baseline="0" noProof="0">
               <a:ln>
@@ -972,7 +1248,7 @@
             <a:fld id="{1804209A-C6D7-496B-8537-5782FDB96C12}" type="datetimeFigureOut">
               <a:rPr lang="en-US" smtClean="0"/>
               <a:pPr/>
-              <a:t>4/14/2026</a:t>
+              <a:t>4/15/2026</a:t>
             </a:fld>
             <a:endParaRPr lang="en-US"/>
           </a:p>
@@ -1185,7 +1461,7 @@
           <a:p>
             <a:fld id="{1804209A-C6D7-496B-8537-5782FDB96C12}" type="datetimeFigureOut">
               <a:rPr lang="en-US" smtClean="0"/>
-              <a:t>4/14/2026</a:t>
+              <a:t>4/15/2026</a:t>
             </a:fld>
             <a:endParaRPr lang="en-US"/>
           </a:p>
@@ -1393,7 +1669,7 @@
           <a:p>
             <a:fld id="{1804209A-C6D7-496B-8537-5782FDB96C12}" type="datetimeFigureOut">
               <a:rPr lang="en-US" smtClean="0"/>
-              <a:t>4/14/2026</a:t>
+              <a:t>4/15/2026</a:t>
             </a:fld>
             <a:endParaRPr lang="en-US"/>
           </a:p>
@@ -1602,7 +1878,7 @@
             <a:fld id="{69C9A885-88C9-4C05-AFCE-22FED3FC0DB3}" type="datetimeFigureOut">
               <a:rPr lang="en-US" smtClean="0"/>
               <a:pPr/>
-              <a:t>4/14/2026</a:t>
+              <a:t>4/15/2026</a:t>
             </a:fld>
             <a:endParaRPr lang="en-US"/>
           </a:p>
@@ -1941,7 +2217,7 @@
             <a:fld id="{1804209A-C6D7-496B-8537-5782FDB96C12}" type="datetimeFigureOut">
               <a:rPr lang="en-US" smtClean="0"/>
               <a:pPr/>
-              <a:t>4/14/2026</a:t>
+              <a:t>4/15/2026</a:t>
             </a:fld>
             <a:endParaRPr lang="en-US"/>
           </a:p>
@@ -2244,7 +2520,7 @@
             <a:fld id="{1804209A-C6D7-496B-8537-5782FDB96C12}" type="datetimeFigureOut">
               <a:rPr lang="en-US" smtClean="0"/>
               <a:pPr/>
-              <a:t>4/14/2026</a:t>
+              <a:t>4/15/2026</a:t>
             </a:fld>
             <a:endParaRPr lang="en-US"/>
           </a:p>
@@ -2524,7 +2800,7 @@
           <a:p>
             <a:fld id="{1804209A-C6D7-496B-8537-5782FDB96C12}" type="datetimeFigureOut">
               <a:rPr lang="en-US" smtClean="0"/>
-              <a:t>4/14/2026</a:t>
+              <a:t>4/15/2026</a:t>
             </a:fld>
             <a:endParaRPr lang="en-US"/>
           </a:p>
@@ -2936,7 +3212,7 @@
           <a:p>
             <a:fld id="{1804209A-C6D7-496B-8537-5782FDB96C12}" type="datetimeFigureOut">
               <a:rPr lang="en-US" smtClean="0"/>
-              <a:t>4/14/2026</a:t>
+              <a:t>4/15/2026</a:t>
             </a:fld>
             <a:endParaRPr lang="en-US"/>
           </a:p>
@@ -3092,7 +3368,7 @@
             <a:fld id="{1804209A-C6D7-496B-8537-5782FDB96C12}" type="datetimeFigureOut">
               <a:rPr lang="en-US" smtClean="0"/>
               <a:pPr/>
-              <a:t>4/14/2026</a:t>
+              <a:t>4/15/2026</a:t>
             </a:fld>
             <a:endParaRPr lang="en-US"/>
           </a:p>
@@ -3220,7 +3496,7 @@
           <a:p>
             <a:fld id="{1804209A-C6D7-496B-8537-5782FDB96C12}" type="datetimeFigureOut">
               <a:rPr lang="en-US" smtClean="0"/>
-              <a:t>4/14/2026</a:t>
+              <a:t>4/15/2026</a:t>
             </a:fld>
             <a:endParaRPr lang="en-US"/>
           </a:p>
@@ -3531,7 +3807,7 @@
           <a:p>
             <a:fld id="{1804209A-C6D7-496B-8537-5782FDB96C12}" type="datetimeFigureOut">
               <a:rPr lang="en-US" smtClean="0"/>
-              <a:t>4/14/2026</a:t>
+              <a:t>4/15/2026</a:t>
             </a:fld>
             <a:endParaRPr lang="en-US"/>
           </a:p>
@@ -3819,7 +4095,7 @@
           <a:p>
             <a:fld id="{1804209A-C6D7-496B-8537-5782FDB96C12}" type="datetimeFigureOut">
               <a:rPr lang="en-US" smtClean="0"/>
-              <a:t>4/14/2026</a:t>
+              <a:t>4/15/2026</a:t>
             </a:fld>
             <a:endParaRPr lang="en-US"/>
           </a:p>
@@ -4063,7 +4339,7 @@
             <a:fld id="{1804209A-C6D7-496B-8537-5782FDB96C12}" type="datetimeFigureOut">
               <a:rPr lang="en-US" smtClean="0"/>
               <a:pPr/>
-              <a:t>4/14/2026</a:t>
+              <a:t>4/15/2026</a:t>
             </a:fld>
             <a:endParaRPr lang="en-US"/>
           </a:p>
@@ -4587,6 +4863,1319 @@
           <a:chExt cx="0" cy="0"/>
         </a:xfrm>
       </p:grpSpPr>
+      <p:sp>
+        <p:nvSpPr>
+          <p:cNvPr id="3" name="Content Placeholder 2">
+            <a:extLst>
+              <a:ext uri="{FF2B5EF4-FFF2-40B4-BE49-F238E27FC236}">
+                <a16:creationId xmlns:a16="http://schemas.microsoft.com/office/drawing/2014/main" id="{C0E2EB01-693A-4C11-9F1C-2BAD441AA387}"/>
+              </a:ext>
+            </a:extLst>
+          </p:cNvPr>
+          <p:cNvSpPr>
+            <a:spLocks noGrp="1"/>
+          </p:cNvSpPr>
+          <p:nvPr>
+            <p:ph idx="1"/>
+          </p:nvPr>
+        </p:nvSpPr>
+        <p:spPr>
+          <a:xfrm>
+            <a:off x="838200" y="1825625"/>
+            <a:ext cx="6578600" cy="4351338"/>
+          </a:xfrm>
+        </p:spPr>
+        <p:txBody>
+          <a:bodyPr>
+            <a:normAutofit/>
+          </a:bodyPr>
+          <a:lstStyle/>
+          <a:p>
+            <a:r>
+              <a:rPr lang="en-US" dirty="0"/>
+              <a:t>Pro Publica examined defendants in Broward County, FL</a:t>
+            </a:r>
+          </a:p>
+          <a:p>
+            <a:pPr marL="548627" lvl="1" indent="0">
+              <a:buNone/>
+            </a:pPr>
+            <a:r>
+              <a:rPr lang="en-US" dirty="0"/>
+              <a:t> </a:t>
+            </a:r>
+          </a:p>
+        </p:txBody>
+      </p:sp>
+      <p:pic>
+        <p:nvPicPr>
+          <p:cNvPr id="1026" name="Picture 2">
+            <a:extLst>
+              <a:ext uri="{FF2B5EF4-FFF2-40B4-BE49-F238E27FC236}">
+                <a16:creationId xmlns:a16="http://schemas.microsoft.com/office/drawing/2014/main" id="{79EC171C-1725-8B9B-01F6-6A6423724F79}"/>
+              </a:ext>
+            </a:extLst>
+          </p:cNvPr>
+          <p:cNvPicPr>
+            <a:picLocks noChangeAspect="1" noChangeArrowheads="1"/>
+          </p:cNvPicPr>
+          <p:nvPr/>
+        </p:nvPicPr>
+        <p:blipFill>
+          <a:blip r:embed="rId2">
+            <a:extLst>
+              <a:ext uri="{28A0092B-C50C-407E-A947-70E740481C1C}">
+                <a14:useLocalDpi xmlns:a14="http://schemas.microsoft.com/office/drawing/2010/main" val="0"/>
+              </a:ext>
+            </a:extLst>
+          </a:blip>
+          <a:srcRect/>
+          <a:stretch>
+            <a:fillRect/>
+          </a:stretch>
+        </p:blipFill>
+        <p:spPr bwMode="auto">
+          <a:xfrm>
+            <a:off x="7716929" y="2144521"/>
+            <a:ext cx="4095750" cy="2838450"/>
+          </a:xfrm>
+          <a:prstGeom prst="rect">
+            <a:avLst/>
+          </a:prstGeom>
+          <a:noFill/>
+          <a:extLst>
+            <a:ext uri="{909E8E84-426E-40DD-AFC4-6F175D3DCCD1}">
+              <a14:hiddenFill xmlns:a14="http://schemas.microsoft.com/office/drawing/2010/main">
+                <a:solidFill>
+                  <a:srgbClr val="FFFFFF"/>
+                </a:solidFill>
+              </a14:hiddenFill>
+            </a:ext>
+          </a:extLst>
+        </p:spPr>
+      </p:pic>
+      <p:pic>
+        <p:nvPicPr>
+          <p:cNvPr id="4" name="Picture 2">
+            <a:extLst>
+              <a:ext uri="{FF2B5EF4-FFF2-40B4-BE49-F238E27FC236}">
+                <a16:creationId xmlns:a16="http://schemas.microsoft.com/office/drawing/2014/main" id="{AC3ACC84-DD9F-5CB8-666C-DC16F8206324}"/>
+              </a:ext>
+            </a:extLst>
+          </p:cNvPr>
+          <p:cNvPicPr>
+            <a:picLocks noChangeAspect="1" noChangeArrowheads="1"/>
+          </p:cNvPicPr>
+          <p:nvPr/>
+        </p:nvPicPr>
+        <p:blipFill>
+          <a:blip r:embed="rId3">
+            <a:extLst>
+              <a:ext uri="{28A0092B-C50C-407E-A947-70E740481C1C}">
+                <a14:useLocalDpi xmlns:a14="http://schemas.microsoft.com/office/drawing/2010/main" val="0"/>
+              </a:ext>
+            </a:extLst>
+          </a:blip>
+          <a:srcRect/>
+          <a:stretch>
+            <a:fillRect/>
+          </a:stretch>
+        </p:blipFill>
+        <p:spPr bwMode="auto">
+          <a:xfrm>
+            <a:off x="379321" y="3429000"/>
+            <a:ext cx="7037479" cy="2838450"/>
+          </a:xfrm>
+          <a:prstGeom prst="rect">
+            <a:avLst/>
+          </a:prstGeom>
+          <a:noFill/>
+          <a:extLst>
+            <a:ext uri="{909E8E84-426E-40DD-AFC4-6F175D3DCCD1}">
+              <a14:hiddenFill xmlns:a14="http://schemas.microsoft.com/office/drawing/2010/main">
+                <a:solidFill>
+                  <a:srgbClr val="FFFFFF"/>
+                </a:solidFill>
+              </a14:hiddenFill>
+            </a:ext>
+          </a:extLst>
+        </p:spPr>
+      </p:pic>
+      <p:sp>
+        <p:nvSpPr>
+          <p:cNvPr id="5" name="Title 1">
+            <a:extLst>
+              <a:ext uri="{FF2B5EF4-FFF2-40B4-BE49-F238E27FC236}">
+                <a16:creationId xmlns:a16="http://schemas.microsoft.com/office/drawing/2014/main" id="{8E888B0A-AF14-D21E-8DA8-4464CB19D49F}"/>
+              </a:ext>
+            </a:extLst>
+          </p:cNvPr>
+          <p:cNvSpPr txBox="1">
+            <a:spLocks/>
+          </p:cNvSpPr>
+          <p:nvPr/>
+        </p:nvSpPr>
+        <p:spPr>
+          <a:xfrm>
+            <a:off x="838200" y="365125"/>
+            <a:ext cx="10515600" cy="1325563"/>
+          </a:xfrm>
+          <a:prstGeom prst="rect">
+            <a:avLst/>
+          </a:prstGeom>
+        </p:spPr>
+        <p:txBody>
+          <a:bodyPr vert="horz" lIns="91440" tIns="45720" rIns="91440" bIns="45720" rtlCol="0" anchor="ctr">
+            <a:normAutofit/>
+          </a:bodyPr>
+          <a:lstStyle>
+            <a:lvl1pPr algn="l" defTabSz="914400" rtl="0" eaLnBrk="1" latinLnBrk="0" hangingPunct="1">
+              <a:lnSpc>
+                <a:spcPct val="90000"/>
+              </a:lnSpc>
+              <a:spcBef>
+                <a:spcPct val="0"/>
+              </a:spcBef>
+              <a:buNone/>
+              <a:defRPr sz="4400" kern="1200">
+                <a:solidFill>
+                  <a:schemeClr val="tx1"/>
+                </a:solidFill>
+                <a:latin typeface="+mj-lt"/>
+                <a:ea typeface="+mj-ea"/>
+                <a:cs typeface="+mj-cs"/>
+              </a:defRPr>
+            </a:lvl1pPr>
+          </a:lstStyle>
+          <a:p>
+            <a:r>
+              <a:rPr lang="en-US" dirty="0" err="1">
+                <a:solidFill>
+                  <a:srgbClr val="C00000"/>
+                </a:solidFill>
+                <a:latin typeface="Cambria" panose="02040503050406030204" pitchFamily="18" charset="0"/>
+                <a:ea typeface="Cambria" panose="02040503050406030204" pitchFamily="18" charset="0"/>
+              </a:rPr>
+              <a:t>Compas</a:t>
+            </a:r>
+            <a:r>
+              <a:rPr lang="en-US" dirty="0">
+                <a:solidFill>
+                  <a:srgbClr val="C00000"/>
+                </a:solidFill>
+                <a:latin typeface="Cambria" panose="02040503050406030204" pitchFamily="18" charset="0"/>
+                <a:ea typeface="Cambria" panose="02040503050406030204" pitchFamily="18" charset="0"/>
+              </a:rPr>
+              <a:t> Tool</a:t>
+            </a:r>
+          </a:p>
+        </p:txBody>
+      </p:sp>
+    </p:spTree>
+    <p:extLst>
+      <p:ext uri="{BB962C8B-B14F-4D97-AF65-F5344CB8AC3E}">
+        <p14:creationId xmlns:p14="http://schemas.microsoft.com/office/powerpoint/2010/main" val="1260883987"/>
+      </p:ext>
+    </p:extLst>
+  </p:cSld>
+  <p:clrMapOvr>
+    <a:masterClrMapping/>
+  </p:clrMapOvr>
+  <mc:AlternateContent xmlns:mc="http://schemas.openxmlformats.org/markup-compatibility/2006" xmlns:p159="http://schemas.microsoft.com/office/powerpoint/2015/09/main">
+    <mc:Choice Requires="p159">
+      <p:transition xmlns:p14="http://schemas.microsoft.com/office/powerpoint/2010/main" spd="slow" p14:dur="2000">
+        <p159:morph option="byObject"/>
+      </p:transition>
+    </mc:Choice>
+    <mc:Fallback xmlns="">
+      <p:transition spd="slow">
+        <p:fade/>
+      </p:transition>
+    </mc:Fallback>
+  </mc:AlternateContent>
+  <p:timing>
+    <p:tnLst>
+      <p:par>
+        <p:cTn id="1" dur="indefinite" restart="never" nodeType="tmRoot">
+          <p:childTnLst>
+            <p:seq concurrent="1" nextAc="seek">
+              <p:cTn id="2" dur="indefinite" nodeType="mainSeq">
+                <p:childTnLst>
+                  <p:par>
+                    <p:cTn id="3" fill="hold">
+                      <p:stCondLst>
+                        <p:cond delay="indefinite"/>
+                      </p:stCondLst>
+                      <p:childTnLst>
+                        <p:par>
+                          <p:cTn id="4" fill="hold">
+                            <p:stCondLst>
+                              <p:cond delay="0"/>
+                            </p:stCondLst>
+                            <p:childTnLst>
+                              <p:par>
+                                <p:cTn id="5" presetID="10" presetClass="entr" presetSubtype="0" fill="hold" nodeType="clickEffect">
+                                  <p:stCondLst>
+                                    <p:cond delay="0"/>
+                                  </p:stCondLst>
+                                  <p:childTnLst>
+                                    <p:set>
+                                      <p:cBhvr>
+                                        <p:cTn id="6" dur="1" fill="hold">
+                                          <p:stCondLst>
+                                            <p:cond delay="0"/>
+                                          </p:stCondLst>
+                                        </p:cTn>
+                                        <p:tgtEl>
+                                          <p:spTgt spid="3">
+                                            <p:txEl>
+                                              <p:pRg st="0" end="0"/>
+                                            </p:txEl>
+                                          </p:spTgt>
+                                        </p:tgtEl>
+                                        <p:attrNameLst>
+                                          <p:attrName>style.visibility</p:attrName>
+                                        </p:attrNameLst>
+                                      </p:cBhvr>
+                                      <p:to>
+                                        <p:strVal val="visible"/>
+                                      </p:to>
+                                    </p:set>
+                                    <p:animEffect transition="in" filter="fade">
+                                      <p:cBhvr>
+                                        <p:cTn id="7" dur="500"/>
+                                        <p:tgtEl>
+                                          <p:spTgt spid="3">
+                                            <p:txEl>
+                                              <p:pRg st="0" end="0"/>
+                                            </p:txEl>
+                                          </p:spTgt>
+                                        </p:tgtEl>
+                                      </p:cBhvr>
+                                    </p:animEffect>
+                                  </p:childTnLst>
+                                </p:cTn>
+                              </p:par>
+                            </p:childTnLst>
+                          </p:cTn>
+                        </p:par>
+                      </p:childTnLst>
+                    </p:cTn>
+                  </p:par>
+                  <p:par>
+                    <p:cTn id="8" fill="hold">
+                      <p:stCondLst>
+                        <p:cond delay="indefinite"/>
+                      </p:stCondLst>
+                      <p:childTnLst>
+                        <p:par>
+                          <p:cTn id="9" fill="hold">
+                            <p:stCondLst>
+                              <p:cond delay="0"/>
+                            </p:stCondLst>
+                            <p:childTnLst>
+                              <p:par>
+                                <p:cTn id="10" presetID="10" presetClass="entr" presetSubtype="0" fill="hold" nodeType="clickEffect">
+                                  <p:stCondLst>
+                                    <p:cond delay="0"/>
+                                  </p:stCondLst>
+                                  <p:childTnLst>
+                                    <p:set>
+                                      <p:cBhvr>
+                                        <p:cTn id="11" dur="1" fill="hold">
+                                          <p:stCondLst>
+                                            <p:cond delay="0"/>
+                                          </p:stCondLst>
+                                        </p:cTn>
+                                        <p:tgtEl>
+                                          <p:spTgt spid="3">
+                                            <p:txEl>
+                                              <p:pRg st="1" end="1"/>
+                                            </p:txEl>
+                                          </p:spTgt>
+                                        </p:tgtEl>
+                                        <p:attrNameLst>
+                                          <p:attrName>style.visibility</p:attrName>
+                                        </p:attrNameLst>
+                                      </p:cBhvr>
+                                      <p:to>
+                                        <p:strVal val="visible"/>
+                                      </p:to>
+                                    </p:set>
+                                    <p:animEffect transition="in" filter="fade">
+                                      <p:cBhvr>
+                                        <p:cTn id="12" dur="500"/>
+                                        <p:tgtEl>
+                                          <p:spTgt spid="3">
+                                            <p:txEl>
+                                              <p:pRg st="1" end="1"/>
+                                            </p:txEl>
+                                          </p:spTgt>
+                                        </p:tgtEl>
+                                      </p:cBhvr>
+                                    </p:animEffect>
+                                  </p:childTnLst>
+                                </p:cTn>
+                              </p:par>
+                            </p:childTnLst>
+                          </p:cTn>
+                        </p:par>
+                      </p:childTnLst>
+                    </p:cTn>
+                  </p:par>
+                </p:childTnLst>
+              </p:cTn>
+              <p:prevCondLst>
+                <p:cond evt="onPrev" delay="0">
+                  <p:tgtEl>
+                    <p:sldTgt/>
+                  </p:tgtEl>
+                </p:cond>
+              </p:prevCondLst>
+              <p:nextCondLst>
+                <p:cond evt="onNext" delay="0">
+                  <p:tgtEl>
+                    <p:sldTgt/>
+                  </p:tgtEl>
+                </p:cond>
+              </p:nextCondLst>
+            </p:seq>
+          </p:childTnLst>
+        </p:cTn>
+      </p:par>
+    </p:tnLst>
+  </p:timing>
+</p:sld>
+</file>
+
+<file path=ppt/slides/slide11.xml><?xml version="1.0" encoding="utf-8"?>
+<p:sld xmlns:a="http://schemas.openxmlformats.org/drawingml/2006/main" xmlns:r="http://schemas.openxmlformats.org/officeDocument/2006/relationships" xmlns:p="http://schemas.openxmlformats.org/presentationml/2006/main">
+  <p:cSld>
+    <p:spTree>
+      <p:nvGrpSpPr>
+        <p:cNvPr id="1" name=""/>
+        <p:cNvGrpSpPr/>
+        <p:nvPr/>
+      </p:nvGrpSpPr>
+      <p:grpSpPr>
+        <a:xfrm>
+          <a:off x="0" y="0"/>
+          <a:ext cx="0" cy="0"/>
+          <a:chOff x="0" y="0"/>
+          <a:chExt cx="0" cy="0"/>
+        </a:xfrm>
+      </p:grpSpPr>
+      <p:pic>
+        <p:nvPicPr>
+          <p:cNvPr id="3074" name="Picture 2" descr="https://img.washingtonpost.com/wp-apps/imrs.php?src=https://img.washingtonpost.com/blogs/monkey-cage/files/2016/10/GOEL-Fig-2.png&amp;w=1484">
+            <a:extLst>
+              <a:ext uri="{FF2B5EF4-FFF2-40B4-BE49-F238E27FC236}">
+                <a16:creationId xmlns:a16="http://schemas.microsoft.com/office/drawing/2014/main" id="{63DEE0F3-52C7-4E5F-9239-C48C5D3B9804}"/>
+              </a:ext>
+            </a:extLst>
+          </p:cNvPr>
+          <p:cNvPicPr>
+            <a:picLocks noChangeAspect="1" noChangeArrowheads="1"/>
+          </p:cNvPicPr>
+          <p:nvPr/>
+        </p:nvPicPr>
+        <p:blipFill>
+          <a:blip r:embed="rId2">
+            <a:extLst>
+              <a:ext uri="{28A0092B-C50C-407E-A947-70E740481C1C}">
+                <a14:useLocalDpi xmlns:a14="http://schemas.microsoft.com/office/drawing/2010/main" val="0"/>
+              </a:ext>
+            </a:extLst>
+          </a:blip>
+          <a:srcRect/>
+          <a:stretch>
+            <a:fillRect/>
+          </a:stretch>
+        </p:blipFill>
+        <p:spPr bwMode="auto">
+          <a:xfrm>
+            <a:off x="401870" y="971550"/>
+            <a:ext cx="11790130" cy="5234941"/>
+          </a:xfrm>
+          <a:prstGeom prst="rect">
+            <a:avLst/>
+          </a:prstGeom>
+          <a:noFill/>
+          <a:extLst>
+            <a:ext uri="{909E8E84-426E-40DD-AFC4-6F175D3DCCD1}">
+              <a14:hiddenFill xmlns:a14="http://schemas.microsoft.com/office/drawing/2010/main">
+                <a:solidFill>
+                  <a:srgbClr val="FFFFFF"/>
+                </a:solidFill>
+              </a14:hiddenFill>
+            </a:ext>
+          </a:extLst>
+        </p:spPr>
+      </p:pic>
+    </p:spTree>
+    <p:extLst>
+      <p:ext uri="{BB962C8B-B14F-4D97-AF65-F5344CB8AC3E}">
+        <p14:creationId xmlns:p14="http://schemas.microsoft.com/office/powerpoint/2010/main" val="2730706500"/>
+      </p:ext>
+    </p:extLst>
+  </p:cSld>
+  <p:clrMapOvr>
+    <a:masterClrMapping/>
+  </p:clrMapOvr>
+  <mc:AlternateContent xmlns:mc="http://schemas.openxmlformats.org/markup-compatibility/2006" xmlns:p159="http://schemas.microsoft.com/office/powerpoint/2015/09/main">
+    <mc:Choice Requires="p159">
+      <p:transition xmlns:p14="http://schemas.microsoft.com/office/powerpoint/2010/main" spd="slow" p14:dur="2000">
+        <p159:morph option="byObject"/>
+      </p:transition>
+    </mc:Choice>
+    <mc:Fallback xmlns="">
+      <p:transition spd="slow">
+        <p:fade/>
+      </p:transition>
+    </mc:Fallback>
+  </mc:AlternateContent>
+</p:sld>
+</file>
+
+<file path=ppt/slides/slide12.xml><?xml version="1.0" encoding="utf-8"?>
+<p:sld xmlns:a="http://schemas.openxmlformats.org/drawingml/2006/main" xmlns:r="http://schemas.openxmlformats.org/officeDocument/2006/relationships" xmlns:p="http://schemas.openxmlformats.org/presentationml/2006/main">
+  <p:cSld>
+    <p:spTree>
+      <p:nvGrpSpPr>
+        <p:cNvPr id="1" name=""/>
+        <p:cNvGrpSpPr/>
+        <p:nvPr/>
+      </p:nvGrpSpPr>
+      <p:grpSpPr>
+        <a:xfrm>
+          <a:off x="0" y="0"/>
+          <a:ext cx="0" cy="0"/>
+          <a:chOff x="0" y="0"/>
+          <a:chExt cx="0" cy="0"/>
+        </a:xfrm>
+      </p:grpSpPr>
+      <mc:AlternateContent xmlns:mc="http://schemas.openxmlformats.org/markup-compatibility/2006" xmlns:a14="http://schemas.microsoft.com/office/drawing/2010/main">
+        <mc:Choice Requires="a14">
+          <p:sp>
+            <p:nvSpPr>
+              <p:cNvPr id="2" name="Content Placeholder 1">
+                <a:extLst>
+                  <a:ext uri="{FF2B5EF4-FFF2-40B4-BE49-F238E27FC236}">
+                    <a16:creationId xmlns:a16="http://schemas.microsoft.com/office/drawing/2014/main" id="{993AC864-185A-488E-8239-B4B6FC907C52}"/>
+                  </a:ext>
+                </a:extLst>
+              </p:cNvPr>
+              <p:cNvSpPr>
+                <a:spLocks noGrp="1"/>
+              </p:cNvSpPr>
+              <p:nvPr>
+                <p:ph idx="1"/>
+              </p:nvPr>
+            </p:nvSpPr>
+            <p:spPr/>
+            <p:txBody>
+              <a:bodyPr/>
+              <a:lstStyle/>
+              <a:p>
+                <a:r>
+                  <a:rPr lang="en-US" dirty="0">
+                    <a:latin typeface="Cambria Math" panose="02040503050406030204" pitchFamily="18" charset="0"/>
+                  </a:rPr>
+                  <a:t>Equal False Positive Rates across groups</a:t>
+                </a:r>
+              </a:p>
+              <a:p>
+                <a:pPr marL="0" indent="0">
+                  <a:buNone/>
+                </a:pPr>
+                <a:endParaRPr lang="en-US" i="1" dirty="0">
+                  <a:latin typeface="Cambria Math" panose="02040503050406030204" pitchFamily="18" charset="0"/>
+                </a:endParaRPr>
+              </a:p>
+              <a:p>
+                <a14:m>
+                  <m:oMath xmlns:m="http://schemas.openxmlformats.org/officeDocument/2006/math">
+                    <m:r>
+                      <a:rPr lang="en-US" b="0" i="1" smtClean="0">
+                        <a:latin typeface="Cambria Math" panose="02040503050406030204" pitchFamily="18" charset="0"/>
+                      </a:rPr>
+                      <m:t>𝑃</m:t>
+                    </m:r>
+                    <m:d>
+                      <m:dPr>
+                        <m:ctrlPr>
+                          <a:rPr lang="en-US" b="0" i="1" smtClean="0">
+                            <a:latin typeface="Cambria Math" panose="02040503050406030204" pitchFamily="18" charset="0"/>
+                          </a:rPr>
+                        </m:ctrlPr>
+                      </m:dPr>
+                      <m:e>
+                        <m:r>
+                          <a:rPr lang="en-US" b="0" i="1" smtClean="0">
+                            <a:latin typeface="Cambria Math" panose="02040503050406030204" pitchFamily="18" charset="0"/>
+                          </a:rPr>
+                          <m:t> </m:t>
+                        </m:r>
+                        <m:acc>
+                          <m:accPr>
+                            <m:chr m:val="̂"/>
+                            <m:ctrlPr>
+                              <a:rPr lang="en-US" b="0" i="1" smtClean="0">
+                                <a:latin typeface="Cambria Math" panose="02040503050406030204" pitchFamily="18" charset="0"/>
+                              </a:rPr>
+                            </m:ctrlPr>
+                          </m:accPr>
+                          <m:e>
+                            <m:r>
+                              <a:rPr lang="en-US" b="0" i="1" smtClean="0">
+                                <a:latin typeface="Cambria Math" panose="02040503050406030204" pitchFamily="18" charset="0"/>
+                              </a:rPr>
+                              <m:t>𝑦</m:t>
+                            </m:r>
+                          </m:e>
+                        </m:acc>
+                        <m:r>
+                          <a:rPr lang="en-US" b="0" i="1" smtClean="0">
+                            <a:latin typeface="Cambria Math" panose="02040503050406030204" pitchFamily="18" charset="0"/>
+                          </a:rPr>
+                          <m:t>=1</m:t>
+                        </m:r>
+                      </m:e>
+                      <m:e>
+                        <m:r>
+                          <a:rPr lang="en-US" b="0" i="1" smtClean="0">
+                            <a:latin typeface="Cambria Math" panose="02040503050406030204" pitchFamily="18" charset="0"/>
+                          </a:rPr>
+                          <m:t>𝑦</m:t>
+                        </m:r>
+                        <m:r>
+                          <a:rPr lang="en-US" b="0" i="1" smtClean="0">
+                            <a:latin typeface="Cambria Math" panose="02040503050406030204" pitchFamily="18" charset="0"/>
+                          </a:rPr>
+                          <m:t>=0, </m:t>
+                        </m:r>
+                        <m:r>
+                          <a:rPr lang="en-US" b="0" i="1" smtClean="0">
+                            <a:latin typeface="Cambria Math" panose="02040503050406030204" pitchFamily="18" charset="0"/>
+                          </a:rPr>
+                          <m:t>𝑟𝑎𝑐𝑒</m:t>
+                        </m:r>
+                        <m:r>
+                          <a:rPr lang="en-US" b="0" i="1" smtClean="0">
+                            <a:latin typeface="Cambria Math" panose="02040503050406030204" pitchFamily="18" charset="0"/>
+                          </a:rPr>
+                          <m:t>=</m:t>
+                        </m:r>
+                        <m:r>
+                          <a:rPr lang="en-US" b="0" i="1" smtClean="0">
+                            <a:latin typeface="Cambria Math" panose="02040503050406030204" pitchFamily="18" charset="0"/>
+                          </a:rPr>
+                          <m:t>𝐵𝑙𝑎𝑐𝑘</m:t>
+                        </m:r>
+                      </m:e>
+                    </m:d>
+                    <m:r>
+                      <a:rPr lang="en-US" b="0" i="1" smtClean="0">
+                        <a:latin typeface="Cambria Math" panose="02040503050406030204" pitchFamily="18" charset="0"/>
+                      </a:rPr>
+                      <m:t>&gt;</m:t>
+                    </m:r>
+                    <m:r>
+                      <a:rPr lang="en-US" i="1">
+                        <a:latin typeface="Cambria Math" panose="02040503050406030204" pitchFamily="18" charset="0"/>
+                      </a:rPr>
+                      <m:t>𝑃</m:t>
+                    </m:r>
+                    <m:r>
+                      <a:rPr lang="en-US" b="0" i="1" smtClean="0">
+                        <a:latin typeface="Cambria Math" panose="02040503050406030204" pitchFamily="18" charset="0"/>
+                      </a:rPr>
+                      <m:t>(</m:t>
+                    </m:r>
+                    <m:acc>
+                      <m:accPr>
+                        <m:chr m:val="̂"/>
+                        <m:ctrlPr>
+                          <a:rPr lang="en-US" i="1">
+                            <a:latin typeface="Cambria Math" panose="02040503050406030204" pitchFamily="18" charset="0"/>
+                          </a:rPr>
+                        </m:ctrlPr>
+                      </m:accPr>
+                      <m:e>
+                        <m:r>
+                          <a:rPr lang="en-US" i="1">
+                            <a:latin typeface="Cambria Math" panose="02040503050406030204" pitchFamily="18" charset="0"/>
+                          </a:rPr>
+                          <m:t>𝑦</m:t>
+                        </m:r>
+                      </m:e>
+                    </m:acc>
+                    <m:r>
+                      <a:rPr lang="en-US" i="1">
+                        <a:latin typeface="Cambria Math" panose="02040503050406030204" pitchFamily="18" charset="0"/>
+                      </a:rPr>
+                      <m:t>=1</m:t>
+                    </m:r>
+                    <m:r>
+                      <a:rPr lang="en-US" b="0" i="1" smtClean="0">
+                        <a:latin typeface="Cambria Math" panose="02040503050406030204" pitchFamily="18" charset="0"/>
+                      </a:rPr>
+                      <m:t>|</m:t>
+                    </m:r>
+                    <m:r>
+                      <a:rPr lang="en-US" b="0" i="1" smtClean="0">
+                        <a:latin typeface="Cambria Math" panose="02040503050406030204" pitchFamily="18" charset="0"/>
+                      </a:rPr>
+                      <m:t>𝑦</m:t>
+                    </m:r>
+                    <m:r>
+                      <a:rPr lang="en-US" b="0" i="1" smtClean="0">
+                        <a:latin typeface="Cambria Math" panose="02040503050406030204" pitchFamily="18" charset="0"/>
+                      </a:rPr>
+                      <m:t>=0, </m:t>
+                    </m:r>
+                    <m:r>
+                      <a:rPr lang="en-US" i="1">
+                        <a:latin typeface="Cambria Math" panose="02040503050406030204" pitchFamily="18" charset="0"/>
+                      </a:rPr>
+                      <m:t>𝑟𝑎𝑐𝑒</m:t>
+                    </m:r>
+                    <m:r>
+                      <a:rPr lang="en-US" i="1">
+                        <a:latin typeface="Cambria Math" panose="02040503050406030204" pitchFamily="18" charset="0"/>
+                      </a:rPr>
+                      <m:t>=</m:t>
+                    </m:r>
+                    <m:r>
+                      <a:rPr lang="en-US" b="0" i="1" smtClean="0">
+                        <a:latin typeface="Cambria Math" panose="02040503050406030204" pitchFamily="18" charset="0"/>
+                      </a:rPr>
+                      <m:t>𝑊h𝑖𝑡𝑒</m:t>
+                    </m:r>
+                    <m:r>
+                      <a:rPr lang="en-US" i="1">
+                        <a:latin typeface="Cambria Math" panose="02040503050406030204" pitchFamily="18" charset="0"/>
+                      </a:rPr>
+                      <m:t>)</m:t>
+                    </m:r>
+                  </m:oMath>
+                </a14:m>
+                <a:endParaRPr lang="en-US" dirty="0"/>
+              </a:p>
+              <a:p>
+                <a:endParaRPr lang="en-US" dirty="0"/>
+              </a:p>
+              <a:p>
+                <a:pPr marL="0" indent="0">
+                  <a:buNone/>
+                </a:pPr>
+                <a:endParaRPr lang="en-US" dirty="0"/>
+              </a:p>
+            </p:txBody>
+          </p:sp>
+        </mc:Choice>
+        <mc:Fallback xmlns="">
+          <p:sp>
+            <p:nvSpPr>
+              <p:cNvPr id="2" name="Content Placeholder 1">
+                <a:extLst>
+                  <a:ext uri="{FF2B5EF4-FFF2-40B4-BE49-F238E27FC236}">
+                    <a16:creationId xmlns:a16="http://schemas.microsoft.com/office/drawing/2014/main" id="{993AC864-185A-488E-8239-B4B6FC907C52}"/>
+                  </a:ext>
+                </a:extLst>
+              </p:cNvPr>
+              <p:cNvSpPr>
+                <a:spLocks noGrp="1" noRot="1" noChangeAspect="1" noMove="1" noResize="1" noEditPoints="1" noAdjustHandles="1" noChangeArrowheads="1" noChangeShapeType="1" noTextEdit="1"/>
+              </p:cNvSpPr>
+              <p:nvPr>
+                <p:ph idx="1"/>
+              </p:nvPr>
+            </p:nvSpPr>
+            <p:spPr>
+              <a:blipFill>
+                <a:blip r:embed="rId2"/>
+                <a:stretch>
+                  <a:fillRect l="-1043" t="-2381"/>
+                </a:stretch>
+              </a:blipFill>
+            </p:spPr>
+            <p:txBody>
+              <a:bodyPr/>
+              <a:lstStyle/>
+              <a:p>
+                <a:r>
+                  <a:rPr lang="en-US">
+                    <a:noFill/>
+                  </a:rPr>
+                  <a:t> </a:t>
+                </a:r>
+              </a:p>
+            </p:txBody>
+          </p:sp>
+        </mc:Fallback>
+      </mc:AlternateContent>
+      <p:sp>
+        <p:nvSpPr>
+          <p:cNvPr id="3" name="Title 1">
+            <a:extLst>
+              <a:ext uri="{FF2B5EF4-FFF2-40B4-BE49-F238E27FC236}">
+                <a16:creationId xmlns:a16="http://schemas.microsoft.com/office/drawing/2014/main" id="{73D08871-F695-5AD6-87F2-BF7B3D05365B}"/>
+              </a:ext>
+            </a:extLst>
+          </p:cNvPr>
+          <p:cNvSpPr txBox="1">
+            <a:spLocks/>
+          </p:cNvSpPr>
+          <p:nvPr/>
+        </p:nvSpPr>
+        <p:spPr>
+          <a:xfrm>
+            <a:off x="838200" y="365125"/>
+            <a:ext cx="10515600" cy="1325563"/>
+          </a:xfrm>
+          <a:prstGeom prst="rect">
+            <a:avLst/>
+          </a:prstGeom>
+        </p:spPr>
+        <p:txBody>
+          <a:bodyPr vert="horz" lIns="91440" tIns="45720" rIns="91440" bIns="45720" rtlCol="0" anchor="ctr">
+            <a:normAutofit/>
+          </a:bodyPr>
+          <a:lstStyle>
+            <a:lvl1pPr algn="l" defTabSz="914400" rtl="0" eaLnBrk="1" latinLnBrk="0" hangingPunct="1">
+              <a:lnSpc>
+                <a:spcPct val="90000"/>
+              </a:lnSpc>
+              <a:spcBef>
+                <a:spcPct val="0"/>
+              </a:spcBef>
+              <a:buNone/>
+              <a:defRPr sz="4400" kern="1200">
+                <a:solidFill>
+                  <a:schemeClr val="tx1"/>
+                </a:solidFill>
+                <a:latin typeface="+mj-lt"/>
+                <a:ea typeface="+mj-ea"/>
+                <a:cs typeface="+mj-cs"/>
+              </a:defRPr>
+            </a:lvl1pPr>
+          </a:lstStyle>
+          <a:p>
+            <a:r>
+              <a:rPr lang="en-US" dirty="0">
+                <a:solidFill>
+                  <a:srgbClr val="C00000"/>
+                </a:solidFill>
+                <a:latin typeface="Cambria" panose="02040503050406030204" pitchFamily="18" charset="0"/>
+                <a:ea typeface="Cambria" panose="02040503050406030204" pitchFamily="18" charset="0"/>
+              </a:rPr>
+              <a:t>What is </a:t>
+            </a:r>
+            <a:r>
+              <a:rPr lang="en-US" dirty="0" err="1">
+                <a:solidFill>
+                  <a:srgbClr val="C00000"/>
+                </a:solidFill>
+                <a:latin typeface="Cambria" panose="02040503050406030204" pitchFamily="18" charset="0"/>
+                <a:ea typeface="Cambria" panose="02040503050406030204" pitchFamily="18" charset="0"/>
+              </a:rPr>
+              <a:t>Compas</a:t>
+            </a:r>
+            <a:endParaRPr lang="en-US" dirty="0">
+              <a:solidFill>
+                <a:srgbClr val="C00000"/>
+              </a:solidFill>
+              <a:latin typeface="Cambria" panose="02040503050406030204" pitchFamily="18" charset="0"/>
+              <a:ea typeface="Cambria" panose="02040503050406030204" pitchFamily="18" charset="0"/>
+            </a:endParaRPr>
+          </a:p>
+        </p:txBody>
+      </p:sp>
+    </p:spTree>
+    <p:extLst>
+      <p:ext uri="{BB962C8B-B14F-4D97-AF65-F5344CB8AC3E}">
+        <p14:creationId xmlns:p14="http://schemas.microsoft.com/office/powerpoint/2010/main" val="1080628939"/>
+      </p:ext>
+    </p:extLst>
+  </p:cSld>
+  <p:clrMapOvr>
+    <a:masterClrMapping/>
+  </p:clrMapOvr>
+  <mc:AlternateContent xmlns:mc="http://schemas.openxmlformats.org/markup-compatibility/2006" xmlns:p159="http://schemas.microsoft.com/office/powerpoint/2015/09/main">
+    <mc:Choice Requires="p159">
+      <p:transition xmlns:p14="http://schemas.microsoft.com/office/powerpoint/2010/main" spd="slow" p14:dur="2000">
+        <p159:morph option="byObject"/>
+      </p:transition>
+    </mc:Choice>
+    <mc:Fallback xmlns="">
+      <p:transition spd="slow">
+        <p:fade/>
+      </p:transition>
+    </mc:Fallback>
+  </mc:AlternateContent>
+</p:sld>
+</file>
+
+<file path=ppt/slides/slide13.xml><?xml version="1.0" encoding="utf-8"?>
+<p:sld xmlns:a="http://schemas.openxmlformats.org/drawingml/2006/main" xmlns:r="http://schemas.openxmlformats.org/officeDocument/2006/relationships" xmlns:p="http://schemas.openxmlformats.org/presentationml/2006/main">
+  <p:cSld>
+    <p:spTree>
+      <p:nvGrpSpPr>
+        <p:cNvPr id="1" name=""/>
+        <p:cNvGrpSpPr/>
+        <p:nvPr/>
+      </p:nvGrpSpPr>
+      <p:grpSpPr>
+        <a:xfrm>
+          <a:off x="0" y="0"/>
+          <a:ext cx="0" cy="0"/>
+          <a:chOff x="0" y="0"/>
+          <a:chExt cx="0" cy="0"/>
+        </a:xfrm>
+      </p:grpSpPr>
+      <p:pic>
+        <p:nvPicPr>
+          <p:cNvPr id="3074" name="Picture 2" descr="https://img.washingtonpost.com/wp-apps/imrs.php?src=https://img.washingtonpost.com/blogs/monkey-cage/files/2016/10/GOEL-Fig-2.png&amp;w=1484">
+            <a:extLst>
+              <a:ext uri="{FF2B5EF4-FFF2-40B4-BE49-F238E27FC236}">
+                <a16:creationId xmlns:a16="http://schemas.microsoft.com/office/drawing/2014/main" id="{63DEE0F3-52C7-4E5F-9239-C48C5D3B9804}"/>
+              </a:ext>
+            </a:extLst>
+          </p:cNvPr>
+          <p:cNvPicPr>
+            <a:picLocks noChangeAspect="1" noChangeArrowheads="1"/>
+          </p:cNvPicPr>
+          <p:nvPr/>
+        </p:nvPicPr>
+        <p:blipFill>
+          <a:blip r:embed="rId2">
+            <a:extLst>
+              <a:ext uri="{28A0092B-C50C-407E-A947-70E740481C1C}">
+                <a14:useLocalDpi xmlns:a14="http://schemas.microsoft.com/office/drawing/2010/main" val="0"/>
+              </a:ext>
+            </a:extLst>
+          </a:blip>
+          <a:srcRect/>
+          <a:stretch>
+            <a:fillRect/>
+          </a:stretch>
+        </p:blipFill>
+        <p:spPr bwMode="auto">
+          <a:xfrm>
+            <a:off x="401870" y="971550"/>
+            <a:ext cx="11790130" cy="5234941"/>
+          </a:xfrm>
+          <a:prstGeom prst="rect">
+            <a:avLst/>
+          </a:prstGeom>
+          <a:noFill/>
+          <a:extLst>
+            <a:ext uri="{909E8E84-426E-40DD-AFC4-6F175D3DCCD1}">
+              <a14:hiddenFill xmlns:a14="http://schemas.microsoft.com/office/drawing/2010/main">
+                <a:solidFill>
+                  <a:srgbClr val="FFFFFF"/>
+                </a:solidFill>
+              </a14:hiddenFill>
+            </a:ext>
+          </a:extLst>
+        </p:spPr>
+      </p:pic>
+      <p:sp>
+        <p:nvSpPr>
+          <p:cNvPr id="4" name="Rectangle 3">
+            <a:extLst>
+              <a:ext uri="{FF2B5EF4-FFF2-40B4-BE49-F238E27FC236}">
+                <a16:creationId xmlns:a16="http://schemas.microsoft.com/office/drawing/2014/main" id="{31B7BDFC-8663-47CF-A8F2-C531D3609B8B}"/>
+              </a:ext>
+            </a:extLst>
+          </p:cNvPr>
+          <p:cNvSpPr/>
+          <p:nvPr/>
+        </p:nvSpPr>
+        <p:spPr>
+          <a:xfrm>
+            <a:off x="1736244" y="3753134"/>
+            <a:ext cx="1680951" cy="1752316"/>
+          </a:xfrm>
+          <a:prstGeom prst="rect">
+            <a:avLst/>
+          </a:prstGeom>
+          <a:solidFill>
+            <a:srgbClr val="92D050"/>
+          </a:solidFill>
+          <a:ln>
+            <a:noFill/>
+          </a:ln>
+        </p:spPr>
+        <p:style>
+          <a:lnRef idx="2">
+            <a:schemeClr val="accent1">
+              <a:shade val="50000"/>
+            </a:schemeClr>
+          </a:lnRef>
+          <a:fillRef idx="1">
+            <a:schemeClr val="accent1"/>
+          </a:fillRef>
+          <a:effectRef idx="0">
+            <a:schemeClr val="accent1"/>
+          </a:effectRef>
+          <a:fontRef idx="minor">
+            <a:schemeClr val="lt1"/>
+          </a:fontRef>
+        </p:style>
+        <p:txBody>
+          <a:bodyPr rtlCol="0" anchor="ctr"/>
+          <a:lstStyle/>
+          <a:p>
+            <a:pPr marL="0" marR="0" lvl="0" indent="0" algn="ctr" defTabSz="914400" rtl="0" eaLnBrk="1" fontAlgn="auto" latinLnBrk="0" hangingPunct="1">
+              <a:lnSpc>
+                <a:spcPct val="100000"/>
+              </a:lnSpc>
+              <a:spcBef>
+                <a:spcPts val="0"/>
+              </a:spcBef>
+              <a:spcAft>
+                <a:spcPts val="0"/>
+              </a:spcAft>
+              <a:buClrTx/>
+              <a:buSzTx/>
+              <a:buFontTx/>
+              <a:buNone/>
+              <a:tabLst/>
+              <a:defRPr/>
+            </a:pPr>
+            <a:endParaRPr kumimoji="0" lang="en-US" sz="1800" b="0" i="0" u="none" strike="noStrike" kern="1200" cap="none" spc="0" normalizeH="0" baseline="0" noProof="0">
+              <a:ln>
+                <a:noFill/>
+              </a:ln>
+              <a:solidFill>
+                <a:prstClr val="white"/>
+              </a:solidFill>
+              <a:effectLst/>
+              <a:uLnTx/>
+              <a:uFillTx/>
+              <a:latin typeface="Calibri" panose="020F0502020204030204"/>
+              <a:ea typeface="+mn-ea"/>
+              <a:cs typeface="+mn-cs"/>
+            </a:endParaRPr>
+          </a:p>
+        </p:txBody>
+      </p:sp>
+      <p:sp>
+        <p:nvSpPr>
+          <p:cNvPr id="6" name="Rectangle 5">
+            <a:extLst>
+              <a:ext uri="{FF2B5EF4-FFF2-40B4-BE49-F238E27FC236}">
+                <a16:creationId xmlns:a16="http://schemas.microsoft.com/office/drawing/2014/main" id="{438224BE-F3E2-4670-85AF-AD28D83F4C79}"/>
+              </a:ext>
+            </a:extLst>
+          </p:cNvPr>
+          <p:cNvSpPr/>
+          <p:nvPr/>
+        </p:nvSpPr>
+        <p:spPr>
+          <a:xfrm>
+            <a:off x="3613597" y="4217158"/>
+            <a:ext cx="1678675" cy="1288292"/>
+          </a:xfrm>
+          <a:prstGeom prst="rect">
+            <a:avLst/>
+          </a:prstGeom>
+          <a:solidFill>
+            <a:srgbClr val="FF0000"/>
+          </a:solidFill>
+          <a:ln>
+            <a:noFill/>
+          </a:ln>
+        </p:spPr>
+        <p:style>
+          <a:lnRef idx="2">
+            <a:schemeClr val="accent1">
+              <a:shade val="50000"/>
+            </a:schemeClr>
+          </a:lnRef>
+          <a:fillRef idx="1">
+            <a:schemeClr val="accent1"/>
+          </a:fillRef>
+          <a:effectRef idx="0">
+            <a:schemeClr val="accent1"/>
+          </a:effectRef>
+          <a:fontRef idx="minor">
+            <a:schemeClr val="lt1"/>
+          </a:fontRef>
+        </p:style>
+        <p:txBody>
+          <a:bodyPr rtlCol="0" anchor="ctr"/>
+          <a:lstStyle/>
+          <a:p>
+            <a:pPr marL="0" marR="0" lvl="0" indent="0" algn="ctr" defTabSz="914400" rtl="0" eaLnBrk="1" fontAlgn="auto" latinLnBrk="0" hangingPunct="1">
+              <a:lnSpc>
+                <a:spcPct val="100000"/>
+              </a:lnSpc>
+              <a:spcBef>
+                <a:spcPts val="0"/>
+              </a:spcBef>
+              <a:spcAft>
+                <a:spcPts val="0"/>
+              </a:spcAft>
+              <a:buClrTx/>
+              <a:buSzTx/>
+              <a:buFontTx/>
+              <a:buNone/>
+              <a:tabLst/>
+              <a:defRPr/>
+            </a:pPr>
+            <a:endParaRPr kumimoji="0" lang="en-US" sz="1800" b="0" i="0" u="none" strike="noStrike" kern="1200" cap="none" spc="0" normalizeH="0" baseline="0" noProof="0">
+              <a:ln>
+                <a:noFill/>
+              </a:ln>
+              <a:solidFill>
+                <a:prstClr val="white"/>
+              </a:solidFill>
+              <a:effectLst/>
+              <a:uLnTx/>
+              <a:uFillTx/>
+              <a:latin typeface="Calibri" panose="020F0502020204030204"/>
+              <a:ea typeface="+mn-ea"/>
+              <a:cs typeface="+mn-cs"/>
+            </a:endParaRPr>
+          </a:p>
+        </p:txBody>
+      </p:sp>
+      <p:sp>
+        <p:nvSpPr>
+          <p:cNvPr id="7" name="Rectangle 6">
+            <a:extLst>
+              <a:ext uri="{FF2B5EF4-FFF2-40B4-BE49-F238E27FC236}">
+                <a16:creationId xmlns:a16="http://schemas.microsoft.com/office/drawing/2014/main" id="{D65B0B0B-092C-4B65-89B6-B984D62000AC}"/>
+              </a:ext>
+            </a:extLst>
+          </p:cNvPr>
+          <p:cNvSpPr/>
+          <p:nvPr/>
+        </p:nvSpPr>
+        <p:spPr>
+          <a:xfrm>
+            <a:off x="6005719" y="3493827"/>
+            <a:ext cx="1680950" cy="2011623"/>
+          </a:xfrm>
+          <a:prstGeom prst="rect">
+            <a:avLst/>
+          </a:prstGeom>
+          <a:solidFill>
+            <a:srgbClr val="92D050"/>
+          </a:solidFill>
+          <a:ln>
+            <a:noFill/>
+          </a:ln>
+        </p:spPr>
+        <p:style>
+          <a:lnRef idx="2">
+            <a:schemeClr val="accent1">
+              <a:shade val="50000"/>
+            </a:schemeClr>
+          </a:lnRef>
+          <a:fillRef idx="1">
+            <a:schemeClr val="accent1"/>
+          </a:fillRef>
+          <a:effectRef idx="0">
+            <a:schemeClr val="accent1"/>
+          </a:effectRef>
+          <a:fontRef idx="minor">
+            <a:schemeClr val="lt1"/>
+          </a:fontRef>
+        </p:style>
+        <p:txBody>
+          <a:bodyPr rtlCol="0" anchor="ctr"/>
+          <a:lstStyle/>
+          <a:p>
+            <a:pPr marL="0" marR="0" lvl="0" indent="0" algn="ctr" defTabSz="914400" rtl="0" eaLnBrk="1" fontAlgn="auto" latinLnBrk="0" hangingPunct="1">
+              <a:lnSpc>
+                <a:spcPct val="100000"/>
+              </a:lnSpc>
+              <a:spcBef>
+                <a:spcPts val="0"/>
+              </a:spcBef>
+              <a:spcAft>
+                <a:spcPts val="0"/>
+              </a:spcAft>
+              <a:buClrTx/>
+              <a:buSzTx/>
+              <a:buFontTx/>
+              <a:buNone/>
+              <a:tabLst/>
+              <a:defRPr/>
+            </a:pPr>
+            <a:endParaRPr kumimoji="0" lang="en-US" sz="1800" b="0" i="0" u="none" strike="noStrike" kern="1200" cap="none" spc="0" normalizeH="0" baseline="0" noProof="0">
+              <a:ln>
+                <a:noFill/>
+              </a:ln>
+              <a:solidFill>
+                <a:prstClr val="white"/>
+              </a:solidFill>
+              <a:effectLst/>
+              <a:uLnTx/>
+              <a:uFillTx/>
+              <a:latin typeface="Calibri" panose="020F0502020204030204"/>
+              <a:ea typeface="+mn-ea"/>
+              <a:cs typeface="+mn-cs"/>
+            </a:endParaRPr>
+          </a:p>
+        </p:txBody>
+      </p:sp>
+      <p:sp>
+        <p:nvSpPr>
+          <p:cNvPr id="8" name="Rectangle 7">
+            <a:extLst>
+              <a:ext uri="{FF2B5EF4-FFF2-40B4-BE49-F238E27FC236}">
+                <a16:creationId xmlns:a16="http://schemas.microsoft.com/office/drawing/2014/main" id="{A3A50C45-E46F-4CFD-AAC9-4107EF23F05C}"/>
+              </a:ext>
+            </a:extLst>
+          </p:cNvPr>
+          <p:cNvSpPr/>
+          <p:nvPr/>
+        </p:nvSpPr>
+        <p:spPr>
+          <a:xfrm>
+            <a:off x="7883071" y="4940490"/>
+            <a:ext cx="1678675" cy="564960"/>
+          </a:xfrm>
+          <a:prstGeom prst="rect">
+            <a:avLst/>
+          </a:prstGeom>
+          <a:solidFill>
+            <a:srgbClr val="FF0000"/>
+          </a:solidFill>
+          <a:ln>
+            <a:noFill/>
+          </a:ln>
+        </p:spPr>
+        <p:style>
+          <a:lnRef idx="2">
+            <a:schemeClr val="accent1">
+              <a:shade val="50000"/>
+            </a:schemeClr>
+          </a:lnRef>
+          <a:fillRef idx="1">
+            <a:schemeClr val="accent1"/>
+          </a:fillRef>
+          <a:effectRef idx="0">
+            <a:schemeClr val="accent1"/>
+          </a:effectRef>
+          <a:fontRef idx="minor">
+            <a:schemeClr val="lt1"/>
+          </a:fontRef>
+        </p:style>
+        <p:txBody>
+          <a:bodyPr rtlCol="0" anchor="ctr"/>
+          <a:lstStyle/>
+          <a:p>
+            <a:pPr marL="0" marR="0" lvl="0" indent="0" algn="ctr" defTabSz="914400" rtl="0" eaLnBrk="1" fontAlgn="auto" latinLnBrk="0" hangingPunct="1">
+              <a:lnSpc>
+                <a:spcPct val="100000"/>
+              </a:lnSpc>
+              <a:spcBef>
+                <a:spcPts val="0"/>
+              </a:spcBef>
+              <a:spcAft>
+                <a:spcPts val="0"/>
+              </a:spcAft>
+              <a:buClrTx/>
+              <a:buSzTx/>
+              <a:buFontTx/>
+              <a:buNone/>
+              <a:tabLst/>
+              <a:defRPr/>
+            </a:pPr>
+            <a:endParaRPr kumimoji="0" lang="en-US" sz="1800" b="0" i="0" u="none" strike="noStrike" kern="1200" cap="none" spc="0" normalizeH="0" baseline="0" noProof="0">
+              <a:ln>
+                <a:noFill/>
+              </a:ln>
+              <a:solidFill>
+                <a:prstClr val="white"/>
+              </a:solidFill>
+              <a:effectLst/>
+              <a:uLnTx/>
+              <a:uFillTx/>
+              <a:latin typeface="Calibri" panose="020F0502020204030204"/>
+              <a:ea typeface="+mn-ea"/>
+              <a:cs typeface="+mn-cs"/>
+            </a:endParaRPr>
+          </a:p>
+        </p:txBody>
+      </p:sp>
+      <p:pic>
+        <p:nvPicPr>
+          <p:cNvPr id="11" name="Picture 10">
+            <a:extLst>
+              <a:ext uri="{FF2B5EF4-FFF2-40B4-BE49-F238E27FC236}">
+                <a16:creationId xmlns:a16="http://schemas.microsoft.com/office/drawing/2014/main" id="{4C1B9E04-D6FA-464C-BC9A-CB369197D65D}"/>
+              </a:ext>
+            </a:extLst>
+          </p:cNvPr>
+          <p:cNvPicPr>
+            <a:picLocks noChangeAspect="1"/>
+          </p:cNvPicPr>
+          <p:nvPr/>
+        </p:nvPicPr>
+        <p:blipFill>
+          <a:blip r:embed="rId3"/>
+          <a:stretch>
+            <a:fillRect/>
+          </a:stretch>
+        </p:blipFill>
+        <p:spPr>
+          <a:xfrm>
+            <a:off x="5053566" y="695628"/>
+            <a:ext cx="1871054" cy="275922"/>
+          </a:xfrm>
+          <a:prstGeom prst="rect">
+            <a:avLst/>
+          </a:prstGeom>
+        </p:spPr>
+      </p:pic>
+    </p:spTree>
+    <p:extLst>
+      <p:ext uri="{BB962C8B-B14F-4D97-AF65-F5344CB8AC3E}">
+        <p14:creationId xmlns:p14="http://schemas.microsoft.com/office/powerpoint/2010/main" val="3069737939"/>
+      </p:ext>
+    </p:extLst>
+  </p:cSld>
+  <p:clrMapOvr>
+    <a:masterClrMapping/>
+  </p:clrMapOvr>
+  <mc:AlternateContent xmlns:mc="http://schemas.openxmlformats.org/markup-compatibility/2006" xmlns:p159="http://schemas.microsoft.com/office/powerpoint/2015/09/main">
+    <mc:Choice Requires="p159">
+      <p:transition xmlns:p14="http://schemas.microsoft.com/office/powerpoint/2010/main" spd="slow" p14:dur="2000">
+        <p159:morph option="byObject"/>
+      </p:transition>
+    </mc:Choice>
+    <mc:Fallback xmlns="">
+      <p:transition spd="slow">
+        <p:fade/>
+      </p:transition>
+    </mc:Fallback>
+  </mc:AlternateContent>
+</p:sld>
+</file>
+
+<file path=ppt/slides/slide14.xml><?xml version="1.0" encoding="utf-8"?>
+<p:sld xmlns:a="http://schemas.openxmlformats.org/drawingml/2006/main" xmlns:r="http://schemas.openxmlformats.org/officeDocument/2006/relationships" xmlns:p="http://schemas.openxmlformats.org/presentationml/2006/main">
+  <p:cSld>
+    <p:spTree>
+      <p:nvGrpSpPr>
+        <p:cNvPr id="1" name=""/>
+        <p:cNvGrpSpPr/>
+        <p:nvPr/>
+      </p:nvGrpSpPr>
+      <p:grpSpPr>
+        <a:xfrm>
+          <a:off x="0" y="0"/>
+          <a:ext cx="0" cy="0"/>
+          <a:chOff x="0" y="0"/>
+          <a:chExt cx="0" cy="0"/>
+        </a:xfrm>
+      </p:grpSpPr>
       <p:pic>
         <p:nvPicPr>
           <p:cNvPr id="3074" name="Picture 2" descr="https://img.washingtonpost.com/wp-apps/imrs.php?src=https://img.washingtonpost.com/blogs/monkey-cage/files/2016/10/GOEL-Fig-2.png&amp;w=1484">
@@ -5078,7 +6667,7 @@
 </p:sld>
 </file>
 
-<file path=ppt/slides/slide11.xml><?xml version="1.0" encoding="utf-8"?>
+<file path=ppt/slides/slide15.xml><?xml version="1.0" encoding="utf-8"?>
 <p:sld xmlns:a="http://schemas.openxmlformats.org/drawingml/2006/main" xmlns:r="http://schemas.openxmlformats.org/officeDocument/2006/relationships" xmlns:p="http://schemas.openxmlformats.org/presentationml/2006/main">
   <p:cSld>
     <p:spTree>
@@ -5471,7 +7060,7 @@
 </p:sld>
 </file>
 
-<file path=ppt/slides/slide12.xml><?xml version="1.0" encoding="utf-8"?>
+<file path=ppt/slides/slide16.xml><?xml version="1.0" encoding="utf-8"?>
 <p:sld xmlns:a="http://schemas.openxmlformats.org/drawingml/2006/main" xmlns:r="http://schemas.openxmlformats.org/officeDocument/2006/relationships" xmlns:p="http://schemas.openxmlformats.org/presentationml/2006/main">
   <p:cSld>
     <p:spTree>
@@ -5914,7 +7503,7 @@
 </p:sld>
 </file>
 
-<file path=ppt/slides/slide13.xml><?xml version="1.0" encoding="utf-8"?>
+<file path=ppt/slides/slide17.xml><?xml version="1.0" encoding="utf-8"?>
 <p:sld xmlns:a="http://schemas.openxmlformats.org/drawingml/2006/main" xmlns:r="http://schemas.openxmlformats.org/officeDocument/2006/relationships" xmlns:p="http://schemas.openxmlformats.org/presentationml/2006/main">
   <p:cSld>
     <p:spTree>
@@ -6422,7 +8011,7 @@
 </p:sld>
 </file>
 
-<file path=ppt/slides/slide14.xml><?xml version="1.0" encoding="utf-8"?>
+<file path=ppt/slides/slide18.xml><?xml version="1.0" encoding="utf-8"?>
 <p:sld xmlns:a="http://schemas.openxmlformats.org/drawingml/2006/main" xmlns:r="http://schemas.openxmlformats.org/officeDocument/2006/relationships" xmlns:p="http://schemas.openxmlformats.org/presentationml/2006/main">
   <p:cSld>
     <p:spTree>
@@ -6838,7 +8427,7 @@
 </p:sld>
 </file>
 
-<file path=ppt/slides/slide15.xml><?xml version="1.0" encoding="utf-8"?>
+<file path=ppt/slides/slide19.xml><?xml version="1.0" encoding="utf-8"?>
 <p:sld xmlns:a="http://schemas.openxmlformats.org/drawingml/2006/main" xmlns:r="http://schemas.openxmlformats.org/officeDocument/2006/relationships" xmlns:p="http://schemas.openxmlformats.org/presentationml/2006/main">
   <p:cSld>
     <p:spTree>
@@ -7281,7 +8870,99 @@
 </p:sld>
 </file>
 
-<file path=ppt/slides/slide16.xml><?xml version="1.0" encoding="utf-8"?>
+<file path=ppt/slides/slide2.xml><?xml version="1.0" encoding="utf-8"?>
+<p:sld xmlns:a="http://schemas.openxmlformats.org/drawingml/2006/main" xmlns:r="http://schemas.openxmlformats.org/officeDocument/2006/relationships" xmlns:p="http://schemas.openxmlformats.org/presentationml/2006/main">
+  <p:cSld>
+    <p:spTree>
+      <p:nvGrpSpPr>
+        <p:cNvPr id="1" name=""/>
+        <p:cNvGrpSpPr/>
+        <p:nvPr/>
+      </p:nvGrpSpPr>
+      <p:grpSpPr>
+        <a:xfrm>
+          <a:off x="0" y="0"/>
+          <a:ext cx="0" cy="0"/>
+          <a:chOff x="0" y="0"/>
+          <a:chExt cx="0" cy="0"/>
+        </a:xfrm>
+      </p:grpSpPr>
+      <p:sp>
+        <p:nvSpPr>
+          <p:cNvPr id="2" name="Title 1"/>
+          <p:cNvSpPr>
+            <a:spLocks noGrp="1"/>
+          </p:cNvSpPr>
+          <p:nvPr>
+            <p:ph type="title"/>
+          </p:nvPr>
+        </p:nvSpPr>
+        <p:spPr/>
+        <p:txBody>
+          <a:bodyPr/>
+          <a:lstStyle/>
+          <a:p>
+            <a:r>
+              <a:t>Two Questions About Algorithmic Systems</a:t>
+            </a:r>
+          </a:p>
+        </p:txBody>
+      </p:sp>
+      <p:sp>
+        <p:nvSpPr>
+          <p:cNvPr id="3" name="Content Placeholder 2"/>
+          <p:cNvSpPr>
+            <a:spLocks noGrp="1"/>
+          </p:cNvSpPr>
+          <p:nvPr>
+            <p:ph idx="1"/>
+          </p:nvPr>
+        </p:nvSpPr>
+        <p:spPr/>
+        <p:txBody>
+          <a:bodyPr wrap="square"/>
+          <a:lstStyle/>
+          <a:p>
+            <a:pPr>
+              <a:spcAft>
+                <a:spcPts val="2200"/>
+              </a:spcAft>
+              <a:defRPr sz="2400"/>
+            </a:pPr>
+            <a:r>
+              <a:rPr b="1"/>
+              <a:t>Fairness: </a:t>
+            </a:r>
+            <a:r>
+              <a:t>Does the system treat different groups similarly?</a:t>
+            </a:r>
+          </a:p>
+          <a:p>
+            <a:pPr>
+              <a:spcBef>
+                <a:spcPts val="2000"/>
+              </a:spcBef>
+              <a:defRPr sz="2400"/>
+            </a:pPr>
+            <a:r>
+              <a:rPr b="1"/>
+              <a:t>Legitimacy: </a:t>
+            </a:r>
+            <a:r>
+              <a:t>Should this system exist at all?</a:t>
+            </a:r>
+          </a:p>
+        </p:txBody>
+      </p:sp>
+    </p:spTree>
+  </p:cSld>
+  <p:clrMapOvr>
+    <a:masterClrMapping/>
+  </p:clrMapOvr>
+</p:sld>
+</file>
+
+<file path=ppt/slides/slide20.xml><?xml version="1.0" encoding="utf-8"?>
 <p:sld xmlns:a="http://schemas.openxmlformats.org/drawingml/2006/main" xmlns:r="http://schemas.openxmlformats.org/officeDocument/2006/relationships" xmlns:p="http://schemas.openxmlformats.org/presentationml/2006/main">
   <p:cSld>
     <p:spTree>
@@ -7789,7 +9470,7 @@
 </p:sld>
 </file>
 
-<file path=ppt/slides/slide17.xml><?xml version="1.0" encoding="utf-8"?>
+<file path=ppt/slides/slide21.xml><?xml version="1.0" encoding="utf-8"?>
 <p:sld xmlns:a="http://schemas.openxmlformats.org/drawingml/2006/main" xmlns:r="http://schemas.openxmlformats.org/officeDocument/2006/relationships" xmlns:p="http://schemas.openxmlformats.org/presentationml/2006/main">
   <p:cSld>
     <p:spTree>
@@ -7862,7 +9543,7 @@
 </p:sld>
 </file>
 
-<file path=ppt/slides/slide18.xml><?xml version="1.0" encoding="utf-8"?>
+<file path=ppt/slides/slide22.xml><?xml version="1.0" encoding="utf-8"?>
 <p:sld xmlns:a="http://schemas.openxmlformats.org/drawingml/2006/main" xmlns:r="http://schemas.openxmlformats.org/officeDocument/2006/relationships" xmlns:p="http://schemas.openxmlformats.org/presentationml/2006/main">
   <p:cSld>
     <p:spTree>
@@ -8651,7 +10332,7 @@
 </p:sld>
 </file>
 
-<file path=ppt/slides/slide19.xml><?xml version="1.0" encoding="utf-8"?>
+<file path=ppt/slides/slide23.xml><?xml version="1.0" encoding="utf-8"?>
 <p:sld xmlns:a="http://schemas.openxmlformats.org/drawingml/2006/main" xmlns:r="http://schemas.openxmlformats.org/officeDocument/2006/relationships" xmlns:p="http://schemas.openxmlformats.org/presentationml/2006/main">
   <p:cSld>
     <p:spTree>
@@ -10942,207 +12623,7 @@
 </p:sld>
 </file>
 
-<file path=ppt/slides/slide2.xml><?xml version="1.0" encoding="utf-8"?>
-<p:sld xmlns:a="http://schemas.openxmlformats.org/drawingml/2006/main" xmlns:r="http://schemas.openxmlformats.org/officeDocument/2006/relationships" xmlns:p="http://schemas.openxmlformats.org/presentationml/2006/main">
-  <p:cSld>
-    <p:spTree>
-      <p:nvGrpSpPr>
-        <p:cNvPr id="1" name=""/>
-        <p:cNvGrpSpPr/>
-        <p:nvPr/>
-      </p:nvGrpSpPr>
-      <p:grpSpPr>
-        <a:xfrm>
-          <a:off x="0" y="0"/>
-          <a:ext cx="0" cy="0"/>
-          <a:chOff x="0" y="0"/>
-          <a:chExt cx="0" cy="0"/>
-        </a:xfrm>
-      </p:grpSpPr>
-      <p:pic>
-        <p:nvPicPr>
-          <p:cNvPr id="4" name="Picture 3">
-            <a:hlinkClick r:id="rId2"/>
-            <a:extLst>
-              <a:ext uri="{FF2B5EF4-FFF2-40B4-BE49-F238E27FC236}">
-                <a16:creationId xmlns:a16="http://schemas.microsoft.com/office/drawing/2014/main" id="{CC148A96-8960-4A34-966D-C7CE0DB8DFE1}"/>
-              </a:ext>
-            </a:extLst>
-          </p:cNvPr>
-          <p:cNvPicPr>
-            <a:picLocks noChangeAspect="1"/>
-          </p:cNvPicPr>
-          <p:nvPr/>
-        </p:nvPicPr>
-        <p:blipFill>
-          <a:blip r:embed="rId3"/>
-          <a:stretch>
-            <a:fillRect/>
-          </a:stretch>
-        </p:blipFill>
-        <p:spPr>
-          <a:xfrm>
-            <a:off x="6139541" y="74645"/>
-            <a:ext cx="5959151" cy="3724469"/>
-          </a:xfrm>
-          <a:prstGeom prst="rect">
-            <a:avLst/>
-          </a:prstGeom>
-        </p:spPr>
-      </p:pic>
-      <p:pic>
-        <p:nvPicPr>
-          <p:cNvPr id="1026" name="Picture 2" descr="Screenshot of a Boston Globe article titled 'Racial bias alleged in Google's ad results'">
-            <a:hlinkClick r:id="rId4"/>
-            <a:extLst>
-              <a:ext uri="{FF2B5EF4-FFF2-40B4-BE49-F238E27FC236}">
-                <a16:creationId xmlns:a16="http://schemas.microsoft.com/office/drawing/2014/main" id="{35703F73-5798-4F87-846C-BC5BE1E4C7AD}"/>
-              </a:ext>
-            </a:extLst>
-          </p:cNvPr>
-          <p:cNvPicPr>
-            <a:picLocks noChangeAspect="1" noChangeArrowheads="1"/>
-          </p:cNvPicPr>
-          <p:nvPr/>
-        </p:nvPicPr>
-        <p:blipFill>
-          <a:blip r:embed="rId5">
-            <a:extLst>
-              <a:ext uri="{28A0092B-C50C-407E-A947-70E740481C1C}">
-                <a14:useLocalDpi xmlns:a14="http://schemas.microsoft.com/office/drawing/2010/main" val="0"/>
-              </a:ext>
-            </a:extLst>
-          </a:blip>
-          <a:srcRect/>
-          <a:stretch>
-            <a:fillRect/>
-          </a:stretch>
-        </p:blipFill>
-        <p:spPr bwMode="auto">
-          <a:xfrm>
-            <a:off x="580087" y="298583"/>
-            <a:ext cx="4803677" cy="3180366"/>
-          </a:xfrm>
-          <a:prstGeom prst="rect">
-            <a:avLst/>
-          </a:prstGeom>
-          <a:noFill/>
-          <a:extLst>
-            <a:ext uri="{909E8E84-426E-40DD-AFC4-6F175D3DCCD1}">
-              <a14:hiddenFill xmlns:a14="http://schemas.microsoft.com/office/drawing/2010/main">
-                <a:solidFill>
-                  <a:srgbClr val="FFFFFF"/>
-                </a:solidFill>
-              </a14:hiddenFill>
-            </a:ext>
-          </a:extLst>
-        </p:spPr>
-      </p:pic>
-      <p:pic>
-        <p:nvPicPr>
-          <p:cNvPr id="1028" name="Picture 4" descr="Image: Algorithms of Oppression">
-            <a:hlinkClick r:id="rId6"/>
-            <a:extLst>
-              <a:ext uri="{FF2B5EF4-FFF2-40B4-BE49-F238E27FC236}">
-                <a16:creationId xmlns:a16="http://schemas.microsoft.com/office/drawing/2014/main" id="{2A49FBDA-EFC7-47D1-AB76-977BF3A1A8A0}"/>
-              </a:ext>
-            </a:extLst>
-          </p:cNvPr>
-          <p:cNvPicPr>
-            <a:picLocks noChangeAspect="1" noChangeArrowheads="1"/>
-          </p:cNvPicPr>
-          <p:nvPr/>
-        </p:nvPicPr>
-        <p:blipFill>
-          <a:blip r:embed="rId7">
-            <a:extLst>
-              <a:ext uri="{28A0092B-C50C-407E-A947-70E740481C1C}">
-                <a14:useLocalDpi xmlns:a14="http://schemas.microsoft.com/office/drawing/2010/main" val="0"/>
-              </a:ext>
-            </a:extLst>
-          </a:blip>
-          <a:srcRect/>
-          <a:stretch>
-            <a:fillRect/>
-          </a:stretch>
-        </p:blipFill>
-        <p:spPr bwMode="auto">
-          <a:xfrm>
-            <a:off x="1464452" y="3668300"/>
-            <a:ext cx="2140858" cy="3180367"/>
-          </a:xfrm>
-          <a:prstGeom prst="rect">
-            <a:avLst/>
-          </a:prstGeom>
-          <a:noFill/>
-          <a:extLst>
-            <a:ext uri="{909E8E84-426E-40DD-AFC4-6F175D3DCCD1}">
-              <a14:hiddenFill xmlns:a14="http://schemas.microsoft.com/office/drawing/2010/main">
-                <a:solidFill>
-                  <a:srgbClr val="FFFFFF"/>
-                </a:solidFill>
-              </a14:hiddenFill>
-            </a:ext>
-          </a:extLst>
-        </p:spPr>
-      </p:pic>
-      <p:pic>
-        <p:nvPicPr>
-          <p:cNvPr id="6" name="Picture 5">
-            <a:hlinkClick r:id="rId8"/>
-            <a:extLst>
-              <a:ext uri="{FF2B5EF4-FFF2-40B4-BE49-F238E27FC236}">
-                <a16:creationId xmlns:a16="http://schemas.microsoft.com/office/drawing/2014/main" id="{39A2DFE0-20F6-4222-9317-6B9AEEE1CE67}"/>
-              </a:ext>
-            </a:extLst>
-          </p:cNvPr>
-          <p:cNvPicPr>
-            <a:picLocks noChangeAspect="1"/>
-          </p:cNvPicPr>
-          <p:nvPr/>
-        </p:nvPicPr>
-        <p:blipFill>
-          <a:blip r:embed="rId9"/>
-          <a:stretch>
-            <a:fillRect/>
-          </a:stretch>
-        </p:blipFill>
-        <p:spPr>
-          <a:xfrm>
-            <a:off x="7566814" y="4183765"/>
-            <a:ext cx="3191255" cy="2283894"/>
-          </a:xfrm>
-          <a:prstGeom prst="rect">
-            <a:avLst/>
-          </a:prstGeom>
-        </p:spPr>
-      </p:pic>
-    </p:spTree>
-    <p:extLst>
-      <p:ext uri="{BB962C8B-B14F-4D97-AF65-F5344CB8AC3E}">
-        <p14:creationId xmlns:p14="http://schemas.microsoft.com/office/powerpoint/2010/main" val="1625008833"/>
-      </p:ext>
-    </p:extLst>
-  </p:cSld>
-  <p:clrMapOvr>
-    <a:masterClrMapping/>
-  </p:clrMapOvr>
-  <mc:AlternateContent xmlns:mc="http://schemas.openxmlformats.org/markup-compatibility/2006" xmlns:p159="http://schemas.microsoft.com/office/powerpoint/2015/09/main">
-    <mc:Choice Requires="p159">
-      <p:transition xmlns:p14="http://schemas.microsoft.com/office/powerpoint/2010/main" spd="slow" p14:dur="2000">
-        <p159:morph option="byObject"/>
-      </p:transition>
-    </mc:Choice>
-    <mc:Fallback xmlns="">
-      <p:transition spd="slow">
-        <p:fade/>
-      </p:transition>
-    </mc:Fallback>
-  </mc:AlternateContent>
-</p:sld>
-</file>
-
-<file path=ppt/slides/slide20.xml><?xml version="1.0" encoding="utf-8"?>
+<file path=ppt/slides/slide24.xml><?xml version="1.0" encoding="utf-8"?>
 <p:sld xmlns:a="http://schemas.openxmlformats.org/drawingml/2006/main" xmlns:r="http://schemas.openxmlformats.org/officeDocument/2006/relationships" xmlns:p="http://schemas.openxmlformats.org/presentationml/2006/main">
   <p:cSld>
     <p:bg>
@@ -11232,7 +12713,7 @@
 </p:sld>
 </file>
 
-<file path=ppt/slides/slide21.xml><?xml version="1.0" encoding="utf-8"?>
+<file path=ppt/slides/slide25.xml><?xml version="1.0" encoding="utf-8"?>
 <p:sld xmlns:a="http://schemas.openxmlformats.org/drawingml/2006/main" xmlns:r="http://schemas.openxmlformats.org/officeDocument/2006/relationships" xmlns:p="http://schemas.openxmlformats.org/presentationml/2006/main">
   <p:cSld>
     <p:spTree>
@@ -13294,7 +14775,7 @@
 </p:sld>
 </file>
 
-<file path=ppt/slides/slide22.xml><?xml version="1.0" encoding="utf-8"?>
+<file path=ppt/slides/slide26.xml><?xml version="1.0" encoding="utf-8"?>
 <p:sld xmlns:a="http://schemas.openxmlformats.org/drawingml/2006/main" xmlns:r="http://schemas.openxmlformats.org/officeDocument/2006/relationships" xmlns:p="http://schemas.openxmlformats.org/presentationml/2006/main">
   <p:cSld>
     <p:spTree>
@@ -16035,7 +17516,7 @@
 </p:sld>
 </file>
 
-<file path=ppt/slides/slide23.xml><?xml version="1.0" encoding="utf-8"?>
+<file path=ppt/slides/slide27.xml><?xml version="1.0" encoding="utf-8"?>
 <p:sld xmlns:a="http://schemas.openxmlformats.org/drawingml/2006/main" xmlns:r="http://schemas.openxmlformats.org/officeDocument/2006/relationships" xmlns:p="http://schemas.openxmlformats.org/presentationml/2006/main">
   <p:cSld>
     <p:spTree>
@@ -17329,7 +18810,7 @@
 </p:sld>
 </file>
 
-<file path=ppt/slides/slide24.xml><?xml version="1.0" encoding="utf-8"?>
+<file path=ppt/slides/slide28.xml><?xml version="1.0" encoding="utf-8"?>
 <p:sld xmlns:a="http://schemas.openxmlformats.org/drawingml/2006/main" xmlns:r="http://schemas.openxmlformats.org/officeDocument/2006/relationships" xmlns:p="http://schemas.openxmlformats.org/presentationml/2006/main">
   <p:cSld>
     <p:spTree>
@@ -18809,7 +20290,7 @@
 </p:sld>
 </file>
 
-<file path=ppt/slides/slide25.xml><?xml version="1.0" encoding="utf-8"?>
+<file path=ppt/slides/slide29.xml><?xml version="1.0" encoding="utf-8"?>
 <p:sld xmlns:a="http://schemas.openxmlformats.org/drawingml/2006/main" xmlns:r="http://schemas.openxmlformats.org/officeDocument/2006/relationships" xmlns:p="http://schemas.openxmlformats.org/presentationml/2006/main">
   <p:cSld>
     <p:spTree>
@@ -20482,7 +21963,166 @@
 </p:sld>
 </file>
 
-<file path=ppt/slides/slide26.xml><?xml version="1.0" encoding="utf-8"?>
+<file path=ppt/slides/slide3.xml><?xml version="1.0" encoding="utf-8"?>
+<p:sld xmlns:a="http://schemas.openxmlformats.org/drawingml/2006/main" xmlns:r="http://schemas.openxmlformats.org/officeDocument/2006/relationships" xmlns:p="http://schemas.openxmlformats.org/presentationml/2006/main">
+  <p:cSld>
+    <p:spTree>
+      <p:nvGrpSpPr>
+        <p:cNvPr id="1" name=""/>
+        <p:cNvGrpSpPr/>
+        <p:nvPr/>
+      </p:nvGrpSpPr>
+      <p:grpSpPr>
+        <a:xfrm>
+          <a:off x="0" y="0"/>
+          <a:ext cx="0" cy="0"/>
+          <a:chOff x="0" y="0"/>
+          <a:chExt cx="0" cy="0"/>
+        </a:xfrm>
+      </p:grpSpPr>
+      <p:sp>
+        <p:nvSpPr>
+          <p:cNvPr id="2" name="Title 1"/>
+          <p:cNvSpPr>
+            <a:spLocks noGrp="1"/>
+          </p:cNvSpPr>
+          <p:nvPr>
+            <p:ph type="title"/>
+          </p:nvPr>
+        </p:nvSpPr>
+        <p:spPr/>
+        <p:txBody>
+          <a:bodyPr/>
+          <a:lstStyle/>
+          <a:p>
+            <a:r>
+              <a:t>What the Textbook Says</a:t>
+            </a:r>
+          </a:p>
+        </p:txBody>
+      </p:sp>
+      <p:sp>
+        <p:nvSpPr>
+          <p:cNvPr id="4" name="Rectangle 3"/>
+          <p:cNvSpPr/>
+          <p:nvPr/>
+        </p:nvSpPr>
+        <p:spPr>
+          <a:xfrm>
+            <a:off x="929640" y="2008505"/>
+            <a:ext cx="27432" cy="1920240"/>
+          </a:xfrm>
+          <a:prstGeom prst="rect">
+            <a:avLst/>
+          </a:prstGeom>
+          <a:solidFill>
+            <a:srgbClr val="6E6E6E"/>
+          </a:solidFill>
+          <a:ln>
+            <a:solidFill>
+              <a:srgbClr val="6E6E6E"/>
+            </a:solidFill>
+          </a:ln>
+        </p:spPr>
+        <p:style>
+          <a:lnRef idx="1">
+            <a:schemeClr val="accent1"/>
+          </a:lnRef>
+          <a:fillRef idx="3">
+            <a:schemeClr val="accent1"/>
+          </a:fillRef>
+          <a:effectRef idx="2">
+            <a:schemeClr val="accent1"/>
+          </a:effectRef>
+          <a:fontRef idx="minor">
+            <a:schemeClr val="lt1"/>
+          </a:fontRef>
+        </p:style>
+        <p:txBody>
+          <a:bodyPr rtlCol="0" anchor="ctr"/>
+          <a:lstStyle/>
+          <a:p>
+            <a:pPr algn="ctr"/>
+            <a:endParaRPr/>
+          </a:p>
+        </p:txBody>
+      </p:sp>
+      <p:sp>
+        <p:nvSpPr>
+          <p:cNvPr id="5" name="TextBox 4"/>
+          <p:cNvSpPr txBox="1"/>
+          <p:nvPr/>
+        </p:nvSpPr>
+        <p:spPr>
+          <a:xfrm>
+            <a:off x="1102858" y="2232788"/>
+            <a:ext cx="9052146" cy="1446550"/>
+          </a:xfrm>
+          <a:prstGeom prst="rect">
+            <a:avLst/>
+          </a:prstGeom>
+          <a:noFill/>
+        </p:spPr>
+        <p:txBody>
+          <a:bodyPr wrap="square">
+            <a:spAutoFit/>
+          </a:bodyPr>
+          <a:lstStyle/>
+          <a:p>
+            <a:r>
+              <a:rPr sz="2200" i="1" dirty="0">
+                <a:solidFill>
+                  <a:srgbClr val="000000"/>
+                </a:solidFill>
+              </a:rPr>
+              <a:t>"The legitimacy question should precede other fairness questions. Debating distributive justice in the context of a fundamentally unjust institution is at best a waste of time, and at worst helps prop up the institution's legitimacy, and is thus counterproductive."</a:t>
+            </a:r>
+          </a:p>
+        </p:txBody>
+      </p:sp>
+      <p:sp>
+        <p:nvSpPr>
+          <p:cNvPr id="6" name="TextBox 5"/>
+          <p:cNvSpPr txBox="1"/>
+          <p:nvPr/>
+        </p:nvSpPr>
+        <p:spPr>
+          <a:xfrm>
+            <a:off x="1478280" y="4340225"/>
+            <a:ext cx="9875520" cy="548640"/>
+          </a:xfrm>
+          <a:prstGeom prst="rect">
+            <a:avLst/>
+          </a:prstGeom>
+          <a:noFill/>
+        </p:spPr>
+        <p:txBody>
+          <a:bodyPr wrap="none">
+            <a:spAutoFit/>
+          </a:bodyPr>
+          <a:lstStyle/>
+          <a:p>
+            <a:pPr algn="r"/>
+            <a:r>
+              <a:rPr sz="1600">
+                <a:solidFill>
+                  <a:srgbClr val="6E6E6E"/>
+                </a:solidFill>
+              </a:rPr>
+              <a:t>— Barocas, Hardt, &amp; Narayanan, Fairness and Machine Learning, Ch. 2</a:t>
+            </a:r>
+          </a:p>
+        </p:txBody>
+      </p:sp>
+    </p:spTree>
+  </p:cSld>
+  <p:clrMapOvr>
+    <a:masterClrMapping/>
+  </p:clrMapOvr>
+</p:sld>
+</file>
+
+<file path=ppt/slides/slide30.xml><?xml version="1.0" encoding="utf-8"?>
 <p:sld xmlns:a="http://schemas.openxmlformats.org/drawingml/2006/main" xmlns:r="http://schemas.openxmlformats.org/officeDocument/2006/relationships" xmlns:p="http://schemas.openxmlformats.org/presentationml/2006/main">
   <p:cSld>
     <p:spTree>
@@ -21465,7 +23105,7 @@
 </p:sld>
 </file>
 
-<file path=ppt/slides/slide27.xml><?xml version="1.0" encoding="utf-8"?>
+<file path=ppt/slides/slide31.xml><?xml version="1.0" encoding="utf-8"?>
 <p:sld xmlns:a="http://schemas.openxmlformats.org/drawingml/2006/main" xmlns:r="http://schemas.openxmlformats.org/officeDocument/2006/relationships" xmlns:p="http://schemas.openxmlformats.org/presentationml/2006/main">
   <p:cSld>
     <p:spTree>
@@ -21519,16 +23159,19 @@
           <a:lstStyle/>
           <a:p>
             <a:r>
+              <a:rPr dirty="0"/>
               <a:t>So far, we have compared different fairness definitions in model outputs</a:t>
             </a:r>
           </a:p>
           <a:p>
             <a:r>
+              <a:rPr dirty="0"/>
               <a:t>Next, we ask where these differences come from</a:t>
             </a:r>
           </a:p>
           <a:p>
             <a:r>
+              <a:rPr dirty="0"/>
               <a:t>The answer may lie in the world, the data, or the labels — not just the model</a:t>
             </a:r>
           </a:p>
@@ -21542,7 +23185,509 @@
 </p:sld>
 </file>
 
-<file path=ppt/slides/slide3.xml><?xml version="1.0" encoding="utf-8"?>
+<file path=ppt/slides/slide4.xml><?xml version="1.0" encoding="utf-8"?>
+<p:sld xmlns:a="http://schemas.openxmlformats.org/drawingml/2006/main" xmlns:r="http://schemas.openxmlformats.org/officeDocument/2006/relationships" xmlns:p="http://schemas.openxmlformats.org/presentationml/2006/main">
+  <p:cSld>
+    <p:spTree>
+      <p:nvGrpSpPr>
+        <p:cNvPr id="1" name=""/>
+        <p:cNvGrpSpPr/>
+        <p:nvPr/>
+      </p:nvGrpSpPr>
+      <p:grpSpPr>
+        <a:xfrm>
+          <a:off x="0" y="0"/>
+          <a:ext cx="0" cy="0"/>
+          <a:chOff x="0" y="0"/>
+          <a:chExt cx="0" cy="0"/>
+        </a:xfrm>
+      </p:grpSpPr>
+      <p:sp>
+        <p:nvSpPr>
+          <p:cNvPr id="2" name="Title 1"/>
+          <p:cNvSpPr>
+            <a:spLocks noGrp="1"/>
+          </p:cNvSpPr>
+          <p:nvPr>
+            <p:ph type="title"/>
+          </p:nvPr>
+        </p:nvSpPr>
+        <p:spPr/>
+        <p:txBody>
+          <a:bodyPr/>
+          <a:lstStyle/>
+          <a:p>
+            <a:r>
+              <a:t>What Legitimacy Asks</a:t>
+            </a:r>
+          </a:p>
+        </p:txBody>
+      </p:sp>
+      <p:sp>
+        <p:nvSpPr>
+          <p:cNvPr id="3" name="Content Placeholder 2"/>
+          <p:cNvSpPr>
+            <a:spLocks noGrp="1"/>
+          </p:cNvSpPr>
+          <p:nvPr>
+            <p:ph idx="1"/>
+          </p:nvPr>
+        </p:nvSpPr>
+        <p:spPr/>
+        <p:txBody>
+          <a:bodyPr wrap="square"/>
+          <a:lstStyle/>
+          <a:p>
+            <a:pPr>
+              <a:spcAft>
+                <a:spcPts val="1000"/>
+              </a:spcAft>
+              <a:defRPr sz="2200"/>
+            </a:pPr>
+            <a:r>
+              <a:rPr dirty="0"/>
+              <a:t>Does the prediction target match the actual goal?</a:t>
+            </a:r>
+          </a:p>
+          <a:p>
+            <a:pPr>
+              <a:spcAft>
+                <a:spcPts val="1000"/>
+              </a:spcAft>
+              <a:defRPr sz="2200"/>
+            </a:pPr>
+            <a:r>
+              <a:rPr dirty="0"/>
+              <a:t>Is the system accurate enough to justify its consequences?</a:t>
+            </a:r>
+          </a:p>
+          <a:p>
+            <a:pPr>
+              <a:spcAft>
+                <a:spcPts val="1000"/>
+              </a:spcAft>
+              <a:defRPr sz="2200"/>
+            </a:pPr>
+            <a:r>
+              <a:rPr dirty="0"/>
+              <a:t>Can people contest decisions made about them?</a:t>
+            </a:r>
+          </a:p>
+          <a:p>
+            <a:pPr>
+              <a:spcAft>
+                <a:spcPts val="1000"/>
+              </a:spcAft>
+              <a:defRPr sz="2200"/>
+            </a:pPr>
+            <a:r>
+              <a:rPr dirty="0"/>
+              <a:t>Does the system respect people's agency?</a:t>
+            </a:r>
+          </a:p>
+          <a:p>
+            <a:pPr>
+              <a:spcAft>
+                <a:spcPts val="1000"/>
+              </a:spcAft>
+              <a:defRPr sz="2200"/>
+            </a:pPr>
+            <a:r>
+              <a:rPr dirty="0"/>
+              <a:t>Is the data a reliable measure of what it claims to measure?</a:t>
+            </a:r>
+          </a:p>
+        </p:txBody>
+      </p:sp>
+    </p:spTree>
+  </p:cSld>
+  <p:clrMapOvr>
+    <a:masterClrMapping/>
+  </p:clrMapOvr>
+</p:sld>
+</file>
+
+<file path=ppt/slides/slide5.xml><?xml version="1.0" encoding="utf-8"?>
+<p:sld xmlns:a="http://schemas.openxmlformats.org/drawingml/2006/main" xmlns:r="http://schemas.openxmlformats.org/officeDocument/2006/relationships" xmlns:p="http://schemas.openxmlformats.org/presentationml/2006/main">
+  <p:cSld>
+    <p:spTree>
+      <p:nvGrpSpPr>
+        <p:cNvPr id="1" name=""/>
+        <p:cNvGrpSpPr/>
+        <p:nvPr/>
+      </p:nvGrpSpPr>
+      <p:grpSpPr>
+        <a:xfrm>
+          <a:off x="0" y="0"/>
+          <a:ext cx="0" cy="0"/>
+          <a:chOff x="0" y="0"/>
+          <a:chExt cx="0" cy="0"/>
+        </a:xfrm>
+      </p:grpSpPr>
+      <p:sp>
+        <p:nvSpPr>
+          <p:cNvPr id="2" name="Title 1"/>
+          <p:cNvSpPr>
+            <a:spLocks noGrp="1"/>
+          </p:cNvSpPr>
+          <p:nvPr>
+            <p:ph type="title"/>
+          </p:nvPr>
+        </p:nvSpPr>
+        <p:spPr/>
+        <p:txBody>
+          <a:bodyPr/>
+          <a:lstStyle/>
+          <a:p>
+            <a:r>
+              <a:t>What This Lecture Does — and Doesn't Do</a:t>
+            </a:r>
+          </a:p>
+        </p:txBody>
+      </p:sp>
+      <p:sp>
+        <p:nvSpPr>
+          <p:cNvPr id="3" name="Content Placeholder 2"/>
+          <p:cNvSpPr>
+            <a:spLocks noGrp="1"/>
+          </p:cNvSpPr>
+          <p:nvPr>
+            <p:ph idx="1"/>
+          </p:nvPr>
+        </p:nvSpPr>
+        <p:spPr/>
+        <p:txBody>
+          <a:bodyPr wrap="square"/>
+          <a:lstStyle/>
+          <a:p>
+            <a:pPr>
+              <a:spcAft>
+                <a:spcPts val="1000"/>
+              </a:spcAft>
+              <a:defRPr sz="2400"/>
+            </a:pPr>
+            <a:r>
+              <a:rPr b="1" dirty="0"/>
+              <a:t>Today we will:</a:t>
+            </a:r>
+          </a:p>
+          <a:p>
+            <a:pPr lvl="1">
+              <a:spcAft>
+                <a:spcPts val="600"/>
+              </a:spcAft>
+              <a:defRPr sz="2200"/>
+            </a:pPr>
+            <a:r>
+              <a:rPr dirty="0"/>
+              <a:t>Learn how to measure fairness in a prediction system's outputs</a:t>
+            </a:r>
+          </a:p>
+          <a:p>
+            <a:pPr lvl="1">
+              <a:spcAft>
+                <a:spcPts val="600"/>
+              </a:spcAft>
+              <a:defRPr sz="2200"/>
+            </a:pPr>
+            <a:r>
+              <a:rPr dirty="0"/>
+              <a:t>See that different fairness definitions conflict with each other</a:t>
+            </a:r>
+          </a:p>
+          <a:p>
+            <a:pPr lvl="1">
+              <a:spcAft>
+                <a:spcPts val="600"/>
+              </a:spcAft>
+              <a:defRPr sz="2200"/>
+            </a:pPr>
+            <a:r>
+              <a:rPr dirty="0"/>
+              <a:t>Understand why they cannot all be satisfied at the same time</a:t>
+            </a:r>
+          </a:p>
+          <a:p>
+            <a:pPr>
+              <a:spcAft>
+                <a:spcPts val="800"/>
+              </a:spcAft>
+            </a:pPr>
+            <a:endParaRPr dirty="0"/>
+          </a:p>
+          <a:p>
+            <a:pPr>
+              <a:spcAft>
+                <a:spcPts val="1000"/>
+              </a:spcAft>
+              <a:defRPr sz="2400"/>
+            </a:pPr>
+            <a:r>
+              <a:rPr b="1" dirty="0"/>
+              <a:t>Today we will not:</a:t>
+            </a:r>
+          </a:p>
+          <a:p>
+            <a:pPr lvl="1">
+              <a:defRPr sz="2200"/>
+            </a:pPr>
+            <a:r>
+              <a:rPr dirty="0"/>
+              <a:t>Ask whether </a:t>
+            </a:r>
+            <a:r>
+              <a:rPr lang="en-US" dirty="0"/>
+              <a:t>pretrial detention</a:t>
+            </a:r>
+            <a:r>
+              <a:rPr dirty="0"/>
+              <a:t> is a legitimate system</a:t>
+            </a:r>
+          </a:p>
+        </p:txBody>
+      </p:sp>
+      <p:sp>
+        <p:nvSpPr>
+          <p:cNvPr id="4" name="TextBox 3"/>
+          <p:cNvSpPr txBox="1"/>
+          <p:nvPr/>
+        </p:nvSpPr>
+        <p:spPr>
+          <a:xfrm>
+            <a:off x="838200" y="5803264"/>
+            <a:ext cx="10515600" cy="457200"/>
+          </a:xfrm>
+          <a:prstGeom prst="rect">
+            <a:avLst/>
+          </a:prstGeom>
+          <a:noFill/>
+        </p:spPr>
+        <p:txBody>
+          <a:bodyPr wrap="none">
+            <a:spAutoFit/>
+          </a:bodyPr>
+          <a:lstStyle/>
+          <a:p>
+            <a:r>
+              <a:rPr sz="1600" dirty="0">
+                <a:solidFill>
+                  <a:srgbClr val="6E6E6E"/>
+                </a:solidFill>
+              </a:rPr>
+              <a:t>Keep this gap in mind.</a:t>
+            </a:r>
+          </a:p>
+        </p:txBody>
+      </p:sp>
+    </p:spTree>
+  </p:cSld>
+  <p:clrMapOvr>
+    <a:masterClrMapping/>
+  </p:clrMapOvr>
+</p:sld>
+</file>
+
+<file path=ppt/slides/slide6.xml><?xml version="1.0" encoding="utf-8"?>
+<p:sld xmlns:a="http://schemas.openxmlformats.org/drawingml/2006/main" xmlns:r="http://schemas.openxmlformats.org/officeDocument/2006/relationships" xmlns:p="http://schemas.openxmlformats.org/presentationml/2006/main">
+  <p:cSld>
+    <p:spTree>
+      <p:nvGrpSpPr>
+        <p:cNvPr id="1" name=""/>
+        <p:cNvGrpSpPr/>
+        <p:nvPr/>
+      </p:nvGrpSpPr>
+      <p:grpSpPr>
+        <a:xfrm>
+          <a:off x="0" y="0"/>
+          <a:ext cx="0" cy="0"/>
+          <a:chOff x="0" y="0"/>
+          <a:chExt cx="0" cy="0"/>
+        </a:xfrm>
+      </p:grpSpPr>
+      <p:pic>
+        <p:nvPicPr>
+          <p:cNvPr id="4" name="Picture 3">
+            <a:hlinkClick r:id="rId2"/>
+            <a:extLst>
+              <a:ext uri="{FF2B5EF4-FFF2-40B4-BE49-F238E27FC236}">
+                <a16:creationId xmlns:a16="http://schemas.microsoft.com/office/drawing/2014/main" id="{CC148A96-8960-4A34-966D-C7CE0DB8DFE1}"/>
+              </a:ext>
+            </a:extLst>
+          </p:cNvPr>
+          <p:cNvPicPr>
+            <a:picLocks noChangeAspect="1"/>
+          </p:cNvPicPr>
+          <p:nvPr/>
+        </p:nvPicPr>
+        <p:blipFill>
+          <a:blip r:embed="rId3"/>
+          <a:stretch>
+            <a:fillRect/>
+          </a:stretch>
+        </p:blipFill>
+        <p:spPr>
+          <a:xfrm>
+            <a:off x="6139541" y="74645"/>
+            <a:ext cx="5959151" cy="3724469"/>
+          </a:xfrm>
+          <a:prstGeom prst="rect">
+            <a:avLst/>
+          </a:prstGeom>
+        </p:spPr>
+      </p:pic>
+      <p:pic>
+        <p:nvPicPr>
+          <p:cNvPr id="1026" name="Picture 2" descr="Screenshot of a Boston Globe article titled 'Racial bias alleged in Google's ad results'">
+            <a:hlinkClick r:id="rId4"/>
+            <a:extLst>
+              <a:ext uri="{FF2B5EF4-FFF2-40B4-BE49-F238E27FC236}">
+                <a16:creationId xmlns:a16="http://schemas.microsoft.com/office/drawing/2014/main" id="{35703F73-5798-4F87-846C-BC5BE1E4C7AD}"/>
+              </a:ext>
+            </a:extLst>
+          </p:cNvPr>
+          <p:cNvPicPr>
+            <a:picLocks noChangeAspect="1" noChangeArrowheads="1"/>
+          </p:cNvPicPr>
+          <p:nvPr/>
+        </p:nvPicPr>
+        <p:blipFill>
+          <a:blip r:embed="rId5">
+            <a:extLst>
+              <a:ext uri="{28A0092B-C50C-407E-A947-70E740481C1C}">
+                <a14:useLocalDpi xmlns:a14="http://schemas.microsoft.com/office/drawing/2010/main" val="0"/>
+              </a:ext>
+            </a:extLst>
+          </a:blip>
+          <a:srcRect/>
+          <a:stretch>
+            <a:fillRect/>
+          </a:stretch>
+        </p:blipFill>
+        <p:spPr bwMode="auto">
+          <a:xfrm>
+            <a:off x="580087" y="298583"/>
+            <a:ext cx="4803677" cy="3180366"/>
+          </a:xfrm>
+          <a:prstGeom prst="rect">
+            <a:avLst/>
+          </a:prstGeom>
+          <a:noFill/>
+          <a:extLst>
+            <a:ext uri="{909E8E84-426E-40DD-AFC4-6F175D3DCCD1}">
+              <a14:hiddenFill xmlns:a14="http://schemas.microsoft.com/office/drawing/2010/main">
+                <a:solidFill>
+                  <a:srgbClr val="FFFFFF"/>
+                </a:solidFill>
+              </a14:hiddenFill>
+            </a:ext>
+          </a:extLst>
+        </p:spPr>
+      </p:pic>
+      <p:pic>
+        <p:nvPicPr>
+          <p:cNvPr id="1028" name="Picture 4" descr="Image: Algorithms of Oppression">
+            <a:hlinkClick r:id="rId6"/>
+            <a:extLst>
+              <a:ext uri="{FF2B5EF4-FFF2-40B4-BE49-F238E27FC236}">
+                <a16:creationId xmlns:a16="http://schemas.microsoft.com/office/drawing/2014/main" id="{2A49FBDA-EFC7-47D1-AB76-977BF3A1A8A0}"/>
+              </a:ext>
+            </a:extLst>
+          </p:cNvPr>
+          <p:cNvPicPr>
+            <a:picLocks noChangeAspect="1" noChangeArrowheads="1"/>
+          </p:cNvPicPr>
+          <p:nvPr/>
+        </p:nvPicPr>
+        <p:blipFill>
+          <a:blip r:embed="rId7">
+            <a:extLst>
+              <a:ext uri="{28A0092B-C50C-407E-A947-70E740481C1C}">
+                <a14:useLocalDpi xmlns:a14="http://schemas.microsoft.com/office/drawing/2010/main" val="0"/>
+              </a:ext>
+            </a:extLst>
+          </a:blip>
+          <a:srcRect/>
+          <a:stretch>
+            <a:fillRect/>
+          </a:stretch>
+        </p:blipFill>
+        <p:spPr bwMode="auto">
+          <a:xfrm>
+            <a:off x="1464452" y="3668300"/>
+            <a:ext cx="2140858" cy="3180367"/>
+          </a:xfrm>
+          <a:prstGeom prst="rect">
+            <a:avLst/>
+          </a:prstGeom>
+          <a:noFill/>
+          <a:extLst>
+            <a:ext uri="{909E8E84-426E-40DD-AFC4-6F175D3DCCD1}">
+              <a14:hiddenFill xmlns:a14="http://schemas.microsoft.com/office/drawing/2010/main">
+                <a:solidFill>
+                  <a:srgbClr val="FFFFFF"/>
+                </a:solidFill>
+              </a14:hiddenFill>
+            </a:ext>
+          </a:extLst>
+        </p:spPr>
+      </p:pic>
+      <p:pic>
+        <p:nvPicPr>
+          <p:cNvPr id="6" name="Picture 5">
+            <a:hlinkClick r:id="rId8"/>
+            <a:extLst>
+              <a:ext uri="{FF2B5EF4-FFF2-40B4-BE49-F238E27FC236}">
+                <a16:creationId xmlns:a16="http://schemas.microsoft.com/office/drawing/2014/main" id="{39A2DFE0-20F6-4222-9317-6B9AEEE1CE67}"/>
+              </a:ext>
+            </a:extLst>
+          </p:cNvPr>
+          <p:cNvPicPr>
+            <a:picLocks noChangeAspect="1"/>
+          </p:cNvPicPr>
+          <p:nvPr/>
+        </p:nvPicPr>
+        <p:blipFill>
+          <a:blip r:embed="rId9"/>
+          <a:stretch>
+            <a:fillRect/>
+          </a:stretch>
+        </p:blipFill>
+        <p:spPr>
+          <a:xfrm>
+            <a:off x="7566814" y="4183765"/>
+            <a:ext cx="3191255" cy="2283894"/>
+          </a:xfrm>
+          <a:prstGeom prst="rect">
+            <a:avLst/>
+          </a:prstGeom>
+        </p:spPr>
+      </p:pic>
+    </p:spTree>
+    <p:extLst>
+      <p:ext uri="{BB962C8B-B14F-4D97-AF65-F5344CB8AC3E}">
+        <p14:creationId xmlns:p14="http://schemas.microsoft.com/office/powerpoint/2010/main" val="1625008833"/>
+      </p:ext>
+    </p:extLst>
+  </p:cSld>
+  <p:clrMapOvr>
+    <a:masterClrMapping/>
+  </p:clrMapOvr>
+  <mc:AlternateContent xmlns:mc="http://schemas.openxmlformats.org/markup-compatibility/2006" xmlns:p159="http://schemas.microsoft.com/office/powerpoint/2015/09/main">
+    <mc:Choice Requires="p159">
+      <p:transition xmlns:p14="http://schemas.microsoft.com/office/powerpoint/2010/main" spd="slow" p14:dur="2000">
+        <p159:morph option="byObject"/>
+      </p:transition>
+    </mc:Choice>
+    <mc:Fallback xmlns="">
+      <p:transition spd="slow">
+        <p:fade/>
+      </p:transition>
+    </mc:Fallback>
+  </mc:AlternateContent>
+</p:sld>
+</file>
+
+<file path=ppt/slides/slide7.xml><?xml version="1.0" encoding="utf-8"?>
 <p:sld xmlns:a="http://schemas.openxmlformats.org/drawingml/2006/main" xmlns:r="http://schemas.openxmlformats.org/officeDocument/2006/relationships" xmlns:p="http://schemas.openxmlformats.org/presentationml/2006/main">
   <p:cSld>
     <p:spTree>
@@ -21619,7 +23764,7 @@
 </p:sld>
 </file>
 
-<file path=ppt/slides/slide4.xml><?xml version="1.0" encoding="utf-8"?>
+<file path=ppt/slides/slide8.xml><?xml version="1.0" encoding="utf-8"?>
 <p:sld xmlns:a="http://schemas.openxmlformats.org/drawingml/2006/main" xmlns:r="http://schemas.openxmlformats.org/officeDocument/2006/relationships" xmlns:p="http://schemas.openxmlformats.org/presentationml/2006/main">
   <p:cSld>
     <p:spTree>
@@ -21753,7 +23898,7 @@
 </p:sld>
 </file>
 
-<file path=ppt/slides/slide5.xml><?xml version="1.0" encoding="utf-8"?>
+<file path=ppt/slides/slide9.xml><?xml version="1.0" encoding="utf-8"?>
 <p:sld xmlns:a="http://schemas.openxmlformats.org/drawingml/2006/main" xmlns:r="http://schemas.openxmlformats.org/officeDocument/2006/relationships" xmlns:p="http://schemas.openxmlformats.org/presentationml/2006/main">
   <p:cSld>
     <p:spTree>
@@ -21946,1319 +24091,6 @@
     <p:extLst>
       <p:ext uri="{BB962C8B-B14F-4D97-AF65-F5344CB8AC3E}">
         <p14:creationId xmlns:p14="http://schemas.microsoft.com/office/powerpoint/2010/main" val="2593333427"/>
-      </p:ext>
-    </p:extLst>
-  </p:cSld>
-  <p:clrMapOvr>
-    <a:masterClrMapping/>
-  </p:clrMapOvr>
-  <mc:AlternateContent xmlns:mc="http://schemas.openxmlformats.org/markup-compatibility/2006" xmlns:p159="http://schemas.microsoft.com/office/powerpoint/2015/09/main">
-    <mc:Choice Requires="p159">
-      <p:transition xmlns:p14="http://schemas.microsoft.com/office/powerpoint/2010/main" spd="slow" p14:dur="2000">
-        <p159:morph option="byObject"/>
-      </p:transition>
-    </mc:Choice>
-    <mc:Fallback xmlns="">
-      <p:transition spd="slow">
-        <p:fade/>
-      </p:transition>
-    </mc:Fallback>
-  </mc:AlternateContent>
-</p:sld>
-</file>
-
-<file path=ppt/slides/slide6.xml><?xml version="1.0" encoding="utf-8"?>
-<p:sld xmlns:a="http://schemas.openxmlformats.org/drawingml/2006/main" xmlns:r="http://schemas.openxmlformats.org/officeDocument/2006/relationships" xmlns:p="http://schemas.openxmlformats.org/presentationml/2006/main">
-  <p:cSld>
-    <p:spTree>
-      <p:nvGrpSpPr>
-        <p:cNvPr id="1" name=""/>
-        <p:cNvGrpSpPr/>
-        <p:nvPr/>
-      </p:nvGrpSpPr>
-      <p:grpSpPr>
-        <a:xfrm>
-          <a:off x="0" y="0"/>
-          <a:ext cx="0" cy="0"/>
-          <a:chOff x="0" y="0"/>
-          <a:chExt cx="0" cy="0"/>
-        </a:xfrm>
-      </p:grpSpPr>
-      <p:sp>
-        <p:nvSpPr>
-          <p:cNvPr id="3" name="Content Placeholder 2">
-            <a:extLst>
-              <a:ext uri="{FF2B5EF4-FFF2-40B4-BE49-F238E27FC236}">
-                <a16:creationId xmlns:a16="http://schemas.microsoft.com/office/drawing/2014/main" id="{C0E2EB01-693A-4C11-9F1C-2BAD441AA387}"/>
-              </a:ext>
-            </a:extLst>
-          </p:cNvPr>
-          <p:cNvSpPr>
-            <a:spLocks noGrp="1"/>
-          </p:cNvSpPr>
-          <p:nvPr>
-            <p:ph idx="1"/>
-          </p:nvPr>
-        </p:nvSpPr>
-        <p:spPr>
-          <a:xfrm>
-            <a:off x="838200" y="1825625"/>
-            <a:ext cx="6578600" cy="4351338"/>
-          </a:xfrm>
-        </p:spPr>
-        <p:txBody>
-          <a:bodyPr>
-            <a:normAutofit/>
-          </a:bodyPr>
-          <a:lstStyle/>
-          <a:p>
-            <a:r>
-              <a:rPr lang="en-US" dirty="0"/>
-              <a:t>Pro Publica examined defendants in Broward County, FL</a:t>
-            </a:r>
-          </a:p>
-          <a:p>
-            <a:pPr marL="548627" lvl="1" indent="0">
-              <a:buNone/>
-            </a:pPr>
-            <a:r>
-              <a:rPr lang="en-US" dirty="0"/>
-              <a:t> </a:t>
-            </a:r>
-          </a:p>
-        </p:txBody>
-      </p:sp>
-      <p:pic>
-        <p:nvPicPr>
-          <p:cNvPr id="1026" name="Picture 2">
-            <a:extLst>
-              <a:ext uri="{FF2B5EF4-FFF2-40B4-BE49-F238E27FC236}">
-                <a16:creationId xmlns:a16="http://schemas.microsoft.com/office/drawing/2014/main" id="{79EC171C-1725-8B9B-01F6-6A6423724F79}"/>
-              </a:ext>
-            </a:extLst>
-          </p:cNvPr>
-          <p:cNvPicPr>
-            <a:picLocks noChangeAspect="1" noChangeArrowheads="1"/>
-          </p:cNvPicPr>
-          <p:nvPr/>
-        </p:nvPicPr>
-        <p:blipFill>
-          <a:blip r:embed="rId2">
-            <a:extLst>
-              <a:ext uri="{28A0092B-C50C-407E-A947-70E740481C1C}">
-                <a14:useLocalDpi xmlns:a14="http://schemas.microsoft.com/office/drawing/2010/main" val="0"/>
-              </a:ext>
-            </a:extLst>
-          </a:blip>
-          <a:srcRect/>
-          <a:stretch>
-            <a:fillRect/>
-          </a:stretch>
-        </p:blipFill>
-        <p:spPr bwMode="auto">
-          <a:xfrm>
-            <a:off x="7716929" y="2144521"/>
-            <a:ext cx="4095750" cy="2838450"/>
-          </a:xfrm>
-          <a:prstGeom prst="rect">
-            <a:avLst/>
-          </a:prstGeom>
-          <a:noFill/>
-          <a:extLst>
-            <a:ext uri="{909E8E84-426E-40DD-AFC4-6F175D3DCCD1}">
-              <a14:hiddenFill xmlns:a14="http://schemas.microsoft.com/office/drawing/2010/main">
-                <a:solidFill>
-                  <a:srgbClr val="FFFFFF"/>
-                </a:solidFill>
-              </a14:hiddenFill>
-            </a:ext>
-          </a:extLst>
-        </p:spPr>
-      </p:pic>
-      <p:pic>
-        <p:nvPicPr>
-          <p:cNvPr id="4" name="Picture 2">
-            <a:extLst>
-              <a:ext uri="{FF2B5EF4-FFF2-40B4-BE49-F238E27FC236}">
-                <a16:creationId xmlns:a16="http://schemas.microsoft.com/office/drawing/2014/main" id="{AC3ACC84-DD9F-5CB8-666C-DC16F8206324}"/>
-              </a:ext>
-            </a:extLst>
-          </p:cNvPr>
-          <p:cNvPicPr>
-            <a:picLocks noChangeAspect="1" noChangeArrowheads="1"/>
-          </p:cNvPicPr>
-          <p:nvPr/>
-        </p:nvPicPr>
-        <p:blipFill>
-          <a:blip r:embed="rId3">
-            <a:extLst>
-              <a:ext uri="{28A0092B-C50C-407E-A947-70E740481C1C}">
-                <a14:useLocalDpi xmlns:a14="http://schemas.microsoft.com/office/drawing/2010/main" val="0"/>
-              </a:ext>
-            </a:extLst>
-          </a:blip>
-          <a:srcRect/>
-          <a:stretch>
-            <a:fillRect/>
-          </a:stretch>
-        </p:blipFill>
-        <p:spPr bwMode="auto">
-          <a:xfrm>
-            <a:off x="379321" y="3429000"/>
-            <a:ext cx="7037479" cy="2838450"/>
-          </a:xfrm>
-          <a:prstGeom prst="rect">
-            <a:avLst/>
-          </a:prstGeom>
-          <a:noFill/>
-          <a:extLst>
-            <a:ext uri="{909E8E84-426E-40DD-AFC4-6F175D3DCCD1}">
-              <a14:hiddenFill xmlns:a14="http://schemas.microsoft.com/office/drawing/2010/main">
-                <a:solidFill>
-                  <a:srgbClr val="FFFFFF"/>
-                </a:solidFill>
-              </a14:hiddenFill>
-            </a:ext>
-          </a:extLst>
-        </p:spPr>
-      </p:pic>
-      <p:sp>
-        <p:nvSpPr>
-          <p:cNvPr id="5" name="Title 1">
-            <a:extLst>
-              <a:ext uri="{FF2B5EF4-FFF2-40B4-BE49-F238E27FC236}">
-                <a16:creationId xmlns:a16="http://schemas.microsoft.com/office/drawing/2014/main" id="{8E888B0A-AF14-D21E-8DA8-4464CB19D49F}"/>
-              </a:ext>
-            </a:extLst>
-          </p:cNvPr>
-          <p:cNvSpPr txBox="1">
-            <a:spLocks/>
-          </p:cNvSpPr>
-          <p:nvPr/>
-        </p:nvSpPr>
-        <p:spPr>
-          <a:xfrm>
-            <a:off x="838200" y="365125"/>
-            <a:ext cx="10515600" cy="1325563"/>
-          </a:xfrm>
-          <a:prstGeom prst="rect">
-            <a:avLst/>
-          </a:prstGeom>
-        </p:spPr>
-        <p:txBody>
-          <a:bodyPr vert="horz" lIns="91440" tIns="45720" rIns="91440" bIns="45720" rtlCol="0" anchor="ctr">
-            <a:normAutofit/>
-          </a:bodyPr>
-          <a:lstStyle>
-            <a:lvl1pPr algn="l" defTabSz="914400" rtl="0" eaLnBrk="1" latinLnBrk="0" hangingPunct="1">
-              <a:lnSpc>
-                <a:spcPct val="90000"/>
-              </a:lnSpc>
-              <a:spcBef>
-                <a:spcPct val="0"/>
-              </a:spcBef>
-              <a:buNone/>
-              <a:defRPr sz="4400" kern="1200">
-                <a:solidFill>
-                  <a:schemeClr val="tx1"/>
-                </a:solidFill>
-                <a:latin typeface="+mj-lt"/>
-                <a:ea typeface="+mj-ea"/>
-                <a:cs typeface="+mj-cs"/>
-              </a:defRPr>
-            </a:lvl1pPr>
-          </a:lstStyle>
-          <a:p>
-            <a:r>
-              <a:rPr lang="en-US" dirty="0" err="1">
-                <a:solidFill>
-                  <a:srgbClr val="C00000"/>
-                </a:solidFill>
-                <a:latin typeface="Cambria" panose="02040503050406030204" pitchFamily="18" charset="0"/>
-                <a:ea typeface="Cambria" panose="02040503050406030204" pitchFamily="18" charset="0"/>
-              </a:rPr>
-              <a:t>Compas</a:t>
-            </a:r>
-            <a:r>
-              <a:rPr lang="en-US" dirty="0">
-                <a:solidFill>
-                  <a:srgbClr val="C00000"/>
-                </a:solidFill>
-                <a:latin typeface="Cambria" panose="02040503050406030204" pitchFamily="18" charset="0"/>
-                <a:ea typeface="Cambria" panose="02040503050406030204" pitchFamily="18" charset="0"/>
-              </a:rPr>
-              <a:t> Tool</a:t>
-            </a:r>
-          </a:p>
-        </p:txBody>
-      </p:sp>
-    </p:spTree>
-    <p:extLst>
-      <p:ext uri="{BB962C8B-B14F-4D97-AF65-F5344CB8AC3E}">
-        <p14:creationId xmlns:p14="http://schemas.microsoft.com/office/powerpoint/2010/main" val="1260883987"/>
-      </p:ext>
-    </p:extLst>
-  </p:cSld>
-  <p:clrMapOvr>
-    <a:masterClrMapping/>
-  </p:clrMapOvr>
-  <mc:AlternateContent xmlns:mc="http://schemas.openxmlformats.org/markup-compatibility/2006" xmlns:p159="http://schemas.microsoft.com/office/powerpoint/2015/09/main">
-    <mc:Choice Requires="p159">
-      <p:transition xmlns:p14="http://schemas.microsoft.com/office/powerpoint/2010/main" spd="slow" p14:dur="2000">
-        <p159:morph option="byObject"/>
-      </p:transition>
-    </mc:Choice>
-    <mc:Fallback xmlns="">
-      <p:transition spd="slow">
-        <p:fade/>
-      </p:transition>
-    </mc:Fallback>
-  </mc:AlternateContent>
-  <p:timing>
-    <p:tnLst>
-      <p:par>
-        <p:cTn id="1" dur="indefinite" restart="never" nodeType="tmRoot">
-          <p:childTnLst>
-            <p:seq concurrent="1" nextAc="seek">
-              <p:cTn id="2" dur="indefinite" nodeType="mainSeq">
-                <p:childTnLst>
-                  <p:par>
-                    <p:cTn id="3" fill="hold">
-                      <p:stCondLst>
-                        <p:cond delay="indefinite"/>
-                      </p:stCondLst>
-                      <p:childTnLst>
-                        <p:par>
-                          <p:cTn id="4" fill="hold">
-                            <p:stCondLst>
-                              <p:cond delay="0"/>
-                            </p:stCondLst>
-                            <p:childTnLst>
-                              <p:par>
-                                <p:cTn id="5" presetID="10" presetClass="entr" presetSubtype="0" fill="hold" nodeType="clickEffect">
-                                  <p:stCondLst>
-                                    <p:cond delay="0"/>
-                                  </p:stCondLst>
-                                  <p:childTnLst>
-                                    <p:set>
-                                      <p:cBhvr>
-                                        <p:cTn id="6" dur="1" fill="hold">
-                                          <p:stCondLst>
-                                            <p:cond delay="0"/>
-                                          </p:stCondLst>
-                                        </p:cTn>
-                                        <p:tgtEl>
-                                          <p:spTgt spid="3">
-                                            <p:txEl>
-                                              <p:pRg st="0" end="0"/>
-                                            </p:txEl>
-                                          </p:spTgt>
-                                        </p:tgtEl>
-                                        <p:attrNameLst>
-                                          <p:attrName>style.visibility</p:attrName>
-                                        </p:attrNameLst>
-                                      </p:cBhvr>
-                                      <p:to>
-                                        <p:strVal val="visible"/>
-                                      </p:to>
-                                    </p:set>
-                                    <p:animEffect transition="in" filter="fade">
-                                      <p:cBhvr>
-                                        <p:cTn id="7" dur="500"/>
-                                        <p:tgtEl>
-                                          <p:spTgt spid="3">
-                                            <p:txEl>
-                                              <p:pRg st="0" end="0"/>
-                                            </p:txEl>
-                                          </p:spTgt>
-                                        </p:tgtEl>
-                                      </p:cBhvr>
-                                    </p:animEffect>
-                                  </p:childTnLst>
-                                </p:cTn>
-                              </p:par>
-                            </p:childTnLst>
-                          </p:cTn>
-                        </p:par>
-                      </p:childTnLst>
-                    </p:cTn>
-                  </p:par>
-                  <p:par>
-                    <p:cTn id="8" fill="hold">
-                      <p:stCondLst>
-                        <p:cond delay="indefinite"/>
-                      </p:stCondLst>
-                      <p:childTnLst>
-                        <p:par>
-                          <p:cTn id="9" fill="hold">
-                            <p:stCondLst>
-                              <p:cond delay="0"/>
-                            </p:stCondLst>
-                            <p:childTnLst>
-                              <p:par>
-                                <p:cTn id="10" presetID="10" presetClass="entr" presetSubtype="0" fill="hold" nodeType="clickEffect">
-                                  <p:stCondLst>
-                                    <p:cond delay="0"/>
-                                  </p:stCondLst>
-                                  <p:childTnLst>
-                                    <p:set>
-                                      <p:cBhvr>
-                                        <p:cTn id="11" dur="1" fill="hold">
-                                          <p:stCondLst>
-                                            <p:cond delay="0"/>
-                                          </p:stCondLst>
-                                        </p:cTn>
-                                        <p:tgtEl>
-                                          <p:spTgt spid="3">
-                                            <p:txEl>
-                                              <p:pRg st="1" end="1"/>
-                                            </p:txEl>
-                                          </p:spTgt>
-                                        </p:tgtEl>
-                                        <p:attrNameLst>
-                                          <p:attrName>style.visibility</p:attrName>
-                                        </p:attrNameLst>
-                                      </p:cBhvr>
-                                      <p:to>
-                                        <p:strVal val="visible"/>
-                                      </p:to>
-                                    </p:set>
-                                    <p:animEffect transition="in" filter="fade">
-                                      <p:cBhvr>
-                                        <p:cTn id="12" dur="500"/>
-                                        <p:tgtEl>
-                                          <p:spTgt spid="3">
-                                            <p:txEl>
-                                              <p:pRg st="1" end="1"/>
-                                            </p:txEl>
-                                          </p:spTgt>
-                                        </p:tgtEl>
-                                      </p:cBhvr>
-                                    </p:animEffect>
-                                  </p:childTnLst>
-                                </p:cTn>
-                              </p:par>
-                            </p:childTnLst>
-                          </p:cTn>
-                        </p:par>
-                      </p:childTnLst>
-                    </p:cTn>
-                  </p:par>
-                </p:childTnLst>
-              </p:cTn>
-              <p:prevCondLst>
-                <p:cond evt="onPrev" delay="0">
-                  <p:tgtEl>
-                    <p:sldTgt/>
-                  </p:tgtEl>
-                </p:cond>
-              </p:prevCondLst>
-              <p:nextCondLst>
-                <p:cond evt="onNext" delay="0">
-                  <p:tgtEl>
-                    <p:sldTgt/>
-                  </p:tgtEl>
-                </p:cond>
-              </p:nextCondLst>
-            </p:seq>
-          </p:childTnLst>
-        </p:cTn>
-      </p:par>
-    </p:tnLst>
-  </p:timing>
-</p:sld>
-</file>
-
-<file path=ppt/slides/slide7.xml><?xml version="1.0" encoding="utf-8"?>
-<p:sld xmlns:a="http://schemas.openxmlformats.org/drawingml/2006/main" xmlns:r="http://schemas.openxmlformats.org/officeDocument/2006/relationships" xmlns:p="http://schemas.openxmlformats.org/presentationml/2006/main">
-  <p:cSld>
-    <p:spTree>
-      <p:nvGrpSpPr>
-        <p:cNvPr id="1" name=""/>
-        <p:cNvGrpSpPr/>
-        <p:nvPr/>
-      </p:nvGrpSpPr>
-      <p:grpSpPr>
-        <a:xfrm>
-          <a:off x="0" y="0"/>
-          <a:ext cx="0" cy="0"/>
-          <a:chOff x="0" y="0"/>
-          <a:chExt cx="0" cy="0"/>
-        </a:xfrm>
-      </p:grpSpPr>
-      <p:pic>
-        <p:nvPicPr>
-          <p:cNvPr id="3074" name="Picture 2" descr="https://img.washingtonpost.com/wp-apps/imrs.php?src=https://img.washingtonpost.com/blogs/monkey-cage/files/2016/10/GOEL-Fig-2.png&amp;w=1484">
-            <a:extLst>
-              <a:ext uri="{FF2B5EF4-FFF2-40B4-BE49-F238E27FC236}">
-                <a16:creationId xmlns:a16="http://schemas.microsoft.com/office/drawing/2014/main" id="{63DEE0F3-52C7-4E5F-9239-C48C5D3B9804}"/>
-              </a:ext>
-            </a:extLst>
-          </p:cNvPr>
-          <p:cNvPicPr>
-            <a:picLocks noChangeAspect="1" noChangeArrowheads="1"/>
-          </p:cNvPicPr>
-          <p:nvPr/>
-        </p:nvPicPr>
-        <p:blipFill>
-          <a:blip r:embed="rId2">
-            <a:extLst>
-              <a:ext uri="{28A0092B-C50C-407E-A947-70E740481C1C}">
-                <a14:useLocalDpi xmlns:a14="http://schemas.microsoft.com/office/drawing/2010/main" val="0"/>
-              </a:ext>
-            </a:extLst>
-          </a:blip>
-          <a:srcRect/>
-          <a:stretch>
-            <a:fillRect/>
-          </a:stretch>
-        </p:blipFill>
-        <p:spPr bwMode="auto">
-          <a:xfrm>
-            <a:off x="401870" y="971550"/>
-            <a:ext cx="11790130" cy="5234941"/>
-          </a:xfrm>
-          <a:prstGeom prst="rect">
-            <a:avLst/>
-          </a:prstGeom>
-          <a:noFill/>
-          <a:extLst>
-            <a:ext uri="{909E8E84-426E-40DD-AFC4-6F175D3DCCD1}">
-              <a14:hiddenFill xmlns:a14="http://schemas.microsoft.com/office/drawing/2010/main">
-                <a:solidFill>
-                  <a:srgbClr val="FFFFFF"/>
-                </a:solidFill>
-              </a14:hiddenFill>
-            </a:ext>
-          </a:extLst>
-        </p:spPr>
-      </p:pic>
-    </p:spTree>
-    <p:extLst>
-      <p:ext uri="{BB962C8B-B14F-4D97-AF65-F5344CB8AC3E}">
-        <p14:creationId xmlns:p14="http://schemas.microsoft.com/office/powerpoint/2010/main" val="2730706500"/>
-      </p:ext>
-    </p:extLst>
-  </p:cSld>
-  <p:clrMapOvr>
-    <a:masterClrMapping/>
-  </p:clrMapOvr>
-  <mc:AlternateContent xmlns:mc="http://schemas.openxmlformats.org/markup-compatibility/2006" xmlns:p159="http://schemas.microsoft.com/office/powerpoint/2015/09/main">
-    <mc:Choice Requires="p159">
-      <p:transition xmlns:p14="http://schemas.microsoft.com/office/powerpoint/2010/main" spd="slow" p14:dur="2000">
-        <p159:morph option="byObject"/>
-      </p:transition>
-    </mc:Choice>
-    <mc:Fallback xmlns="">
-      <p:transition spd="slow">
-        <p:fade/>
-      </p:transition>
-    </mc:Fallback>
-  </mc:AlternateContent>
-</p:sld>
-</file>
-
-<file path=ppt/slides/slide8.xml><?xml version="1.0" encoding="utf-8"?>
-<p:sld xmlns:a="http://schemas.openxmlformats.org/drawingml/2006/main" xmlns:r="http://schemas.openxmlformats.org/officeDocument/2006/relationships" xmlns:p="http://schemas.openxmlformats.org/presentationml/2006/main">
-  <p:cSld>
-    <p:spTree>
-      <p:nvGrpSpPr>
-        <p:cNvPr id="1" name=""/>
-        <p:cNvGrpSpPr/>
-        <p:nvPr/>
-      </p:nvGrpSpPr>
-      <p:grpSpPr>
-        <a:xfrm>
-          <a:off x="0" y="0"/>
-          <a:ext cx="0" cy="0"/>
-          <a:chOff x="0" y="0"/>
-          <a:chExt cx="0" cy="0"/>
-        </a:xfrm>
-      </p:grpSpPr>
-      <mc:AlternateContent xmlns:mc="http://schemas.openxmlformats.org/markup-compatibility/2006" xmlns:a14="http://schemas.microsoft.com/office/drawing/2010/main">
-        <mc:Choice Requires="a14">
-          <p:sp>
-            <p:nvSpPr>
-              <p:cNvPr id="2" name="Content Placeholder 1">
-                <a:extLst>
-                  <a:ext uri="{FF2B5EF4-FFF2-40B4-BE49-F238E27FC236}">
-                    <a16:creationId xmlns:a16="http://schemas.microsoft.com/office/drawing/2014/main" id="{993AC864-185A-488E-8239-B4B6FC907C52}"/>
-                  </a:ext>
-                </a:extLst>
-              </p:cNvPr>
-              <p:cNvSpPr>
-                <a:spLocks noGrp="1"/>
-              </p:cNvSpPr>
-              <p:nvPr>
-                <p:ph idx="1"/>
-              </p:nvPr>
-            </p:nvSpPr>
-            <p:spPr/>
-            <p:txBody>
-              <a:bodyPr/>
-              <a:lstStyle/>
-              <a:p>
-                <a:r>
-                  <a:rPr lang="en-US" dirty="0">
-                    <a:latin typeface="Cambria Math" panose="02040503050406030204" pitchFamily="18" charset="0"/>
-                  </a:rPr>
-                  <a:t>Equal False Positive Rates across groups</a:t>
-                </a:r>
-              </a:p>
-              <a:p>
-                <a:pPr marL="0" indent="0">
-                  <a:buNone/>
-                </a:pPr>
-                <a:endParaRPr lang="en-US" i="1" dirty="0">
-                  <a:latin typeface="Cambria Math" panose="02040503050406030204" pitchFamily="18" charset="0"/>
-                </a:endParaRPr>
-              </a:p>
-              <a:p>
-                <a14:m>
-                  <m:oMath xmlns:m="http://schemas.openxmlformats.org/officeDocument/2006/math">
-                    <m:r>
-                      <a:rPr lang="en-US" b="0" i="1" smtClean="0">
-                        <a:latin typeface="Cambria Math" panose="02040503050406030204" pitchFamily="18" charset="0"/>
-                      </a:rPr>
-                      <m:t>𝑃</m:t>
-                    </m:r>
-                    <m:d>
-                      <m:dPr>
-                        <m:ctrlPr>
-                          <a:rPr lang="en-US" b="0" i="1" smtClean="0">
-                            <a:latin typeface="Cambria Math" panose="02040503050406030204" pitchFamily="18" charset="0"/>
-                          </a:rPr>
-                        </m:ctrlPr>
-                      </m:dPr>
-                      <m:e>
-                        <m:r>
-                          <a:rPr lang="en-US" b="0" i="1" smtClean="0">
-                            <a:latin typeface="Cambria Math" panose="02040503050406030204" pitchFamily="18" charset="0"/>
-                          </a:rPr>
-                          <m:t> </m:t>
-                        </m:r>
-                        <m:acc>
-                          <m:accPr>
-                            <m:chr m:val="̂"/>
-                            <m:ctrlPr>
-                              <a:rPr lang="en-US" b="0" i="1" smtClean="0">
-                                <a:latin typeface="Cambria Math" panose="02040503050406030204" pitchFamily="18" charset="0"/>
-                              </a:rPr>
-                            </m:ctrlPr>
-                          </m:accPr>
-                          <m:e>
-                            <m:r>
-                              <a:rPr lang="en-US" b="0" i="1" smtClean="0">
-                                <a:latin typeface="Cambria Math" panose="02040503050406030204" pitchFamily="18" charset="0"/>
-                              </a:rPr>
-                              <m:t>𝑦</m:t>
-                            </m:r>
-                          </m:e>
-                        </m:acc>
-                        <m:r>
-                          <a:rPr lang="en-US" b="0" i="1" smtClean="0">
-                            <a:latin typeface="Cambria Math" panose="02040503050406030204" pitchFamily="18" charset="0"/>
-                          </a:rPr>
-                          <m:t>=1</m:t>
-                        </m:r>
-                      </m:e>
-                      <m:e>
-                        <m:r>
-                          <a:rPr lang="en-US" b="0" i="1" smtClean="0">
-                            <a:latin typeface="Cambria Math" panose="02040503050406030204" pitchFamily="18" charset="0"/>
-                          </a:rPr>
-                          <m:t>𝑦</m:t>
-                        </m:r>
-                        <m:r>
-                          <a:rPr lang="en-US" b="0" i="1" smtClean="0">
-                            <a:latin typeface="Cambria Math" panose="02040503050406030204" pitchFamily="18" charset="0"/>
-                          </a:rPr>
-                          <m:t>=0, </m:t>
-                        </m:r>
-                        <m:r>
-                          <a:rPr lang="en-US" b="0" i="1" smtClean="0">
-                            <a:latin typeface="Cambria Math" panose="02040503050406030204" pitchFamily="18" charset="0"/>
-                          </a:rPr>
-                          <m:t>𝑟𝑎𝑐𝑒</m:t>
-                        </m:r>
-                        <m:r>
-                          <a:rPr lang="en-US" b="0" i="1" smtClean="0">
-                            <a:latin typeface="Cambria Math" panose="02040503050406030204" pitchFamily="18" charset="0"/>
-                          </a:rPr>
-                          <m:t>=</m:t>
-                        </m:r>
-                        <m:r>
-                          <a:rPr lang="en-US" b="0" i="1" smtClean="0">
-                            <a:latin typeface="Cambria Math" panose="02040503050406030204" pitchFamily="18" charset="0"/>
-                          </a:rPr>
-                          <m:t>𝐵𝑙𝑎𝑐𝑘</m:t>
-                        </m:r>
-                      </m:e>
-                    </m:d>
-                    <m:r>
-                      <a:rPr lang="en-US" b="0" i="1" smtClean="0">
-                        <a:latin typeface="Cambria Math" panose="02040503050406030204" pitchFamily="18" charset="0"/>
-                      </a:rPr>
-                      <m:t>&gt;</m:t>
-                    </m:r>
-                    <m:r>
-                      <a:rPr lang="en-US" i="1">
-                        <a:latin typeface="Cambria Math" panose="02040503050406030204" pitchFamily="18" charset="0"/>
-                      </a:rPr>
-                      <m:t>𝑃</m:t>
-                    </m:r>
-                    <m:r>
-                      <a:rPr lang="en-US" b="0" i="1" smtClean="0">
-                        <a:latin typeface="Cambria Math" panose="02040503050406030204" pitchFamily="18" charset="0"/>
-                      </a:rPr>
-                      <m:t>(</m:t>
-                    </m:r>
-                    <m:acc>
-                      <m:accPr>
-                        <m:chr m:val="̂"/>
-                        <m:ctrlPr>
-                          <a:rPr lang="en-US" i="1">
-                            <a:latin typeface="Cambria Math" panose="02040503050406030204" pitchFamily="18" charset="0"/>
-                          </a:rPr>
-                        </m:ctrlPr>
-                      </m:accPr>
-                      <m:e>
-                        <m:r>
-                          <a:rPr lang="en-US" i="1">
-                            <a:latin typeface="Cambria Math" panose="02040503050406030204" pitchFamily="18" charset="0"/>
-                          </a:rPr>
-                          <m:t>𝑦</m:t>
-                        </m:r>
-                      </m:e>
-                    </m:acc>
-                    <m:r>
-                      <a:rPr lang="en-US" i="1">
-                        <a:latin typeface="Cambria Math" panose="02040503050406030204" pitchFamily="18" charset="0"/>
-                      </a:rPr>
-                      <m:t>=1</m:t>
-                    </m:r>
-                    <m:r>
-                      <a:rPr lang="en-US" b="0" i="1" smtClean="0">
-                        <a:latin typeface="Cambria Math" panose="02040503050406030204" pitchFamily="18" charset="0"/>
-                      </a:rPr>
-                      <m:t>|</m:t>
-                    </m:r>
-                    <m:r>
-                      <a:rPr lang="en-US" b="0" i="1" smtClean="0">
-                        <a:latin typeface="Cambria Math" panose="02040503050406030204" pitchFamily="18" charset="0"/>
-                      </a:rPr>
-                      <m:t>𝑦</m:t>
-                    </m:r>
-                    <m:r>
-                      <a:rPr lang="en-US" b="0" i="1" smtClean="0">
-                        <a:latin typeface="Cambria Math" panose="02040503050406030204" pitchFamily="18" charset="0"/>
-                      </a:rPr>
-                      <m:t>=0, </m:t>
-                    </m:r>
-                    <m:r>
-                      <a:rPr lang="en-US" i="1">
-                        <a:latin typeface="Cambria Math" panose="02040503050406030204" pitchFamily="18" charset="0"/>
-                      </a:rPr>
-                      <m:t>𝑟𝑎𝑐𝑒</m:t>
-                    </m:r>
-                    <m:r>
-                      <a:rPr lang="en-US" i="1">
-                        <a:latin typeface="Cambria Math" panose="02040503050406030204" pitchFamily="18" charset="0"/>
-                      </a:rPr>
-                      <m:t>=</m:t>
-                    </m:r>
-                    <m:r>
-                      <a:rPr lang="en-US" b="0" i="1" smtClean="0">
-                        <a:latin typeface="Cambria Math" panose="02040503050406030204" pitchFamily="18" charset="0"/>
-                      </a:rPr>
-                      <m:t>𝑊h𝑖𝑡𝑒</m:t>
-                    </m:r>
-                    <m:r>
-                      <a:rPr lang="en-US" i="1">
-                        <a:latin typeface="Cambria Math" panose="02040503050406030204" pitchFamily="18" charset="0"/>
-                      </a:rPr>
-                      <m:t>)</m:t>
-                    </m:r>
-                  </m:oMath>
-                </a14:m>
-                <a:endParaRPr lang="en-US" dirty="0"/>
-              </a:p>
-              <a:p>
-                <a:endParaRPr lang="en-US" dirty="0"/>
-              </a:p>
-              <a:p>
-                <a:pPr marL="0" indent="0">
-                  <a:buNone/>
-                </a:pPr>
-                <a:endParaRPr lang="en-US" dirty="0"/>
-              </a:p>
-            </p:txBody>
-          </p:sp>
-        </mc:Choice>
-        <mc:Fallback xmlns="">
-          <p:sp>
-            <p:nvSpPr>
-              <p:cNvPr id="2" name="Content Placeholder 1">
-                <a:extLst>
-                  <a:ext uri="{FF2B5EF4-FFF2-40B4-BE49-F238E27FC236}">
-                    <a16:creationId xmlns:a16="http://schemas.microsoft.com/office/drawing/2014/main" id="{993AC864-185A-488E-8239-B4B6FC907C52}"/>
-                  </a:ext>
-                </a:extLst>
-              </p:cNvPr>
-              <p:cNvSpPr>
-                <a:spLocks noGrp="1" noRot="1" noChangeAspect="1" noMove="1" noResize="1" noEditPoints="1" noAdjustHandles="1" noChangeArrowheads="1" noChangeShapeType="1" noTextEdit="1"/>
-              </p:cNvSpPr>
-              <p:nvPr>
-                <p:ph idx="1"/>
-              </p:nvPr>
-            </p:nvSpPr>
-            <p:spPr>
-              <a:blipFill>
-                <a:blip r:embed="rId2"/>
-                <a:stretch>
-                  <a:fillRect l="-1043" t="-2381"/>
-                </a:stretch>
-              </a:blipFill>
-            </p:spPr>
-            <p:txBody>
-              <a:bodyPr/>
-              <a:lstStyle/>
-              <a:p>
-                <a:r>
-                  <a:rPr lang="en-US">
-                    <a:noFill/>
-                  </a:rPr>
-                  <a:t> </a:t>
-                </a:r>
-              </a:p>
-            </p:txBody>
-          </p:sp>
-        </mc:Fallback>
-      </mc:AlternateContent>
-      <p:sp>
-        <p:nvSpPr>
-          <p:cNvPr id="3" name="Title 1">
-            <a:extLst>
-              <a:ext uri="{FF2B5EF4-FFF2-40B4-BE49-F238E27FC236}">
-                <a16:creationId xmlns:a16="http://schemas.microsoft.com/office/drawing/2014/main" id="{73D08871-F695-5AD6-87F2-BF7B3D05365B}"/>
-              </a:ext>
-            </a:extLst>
-          </p:cNvPr>
-          <p:cNvSpPr txBox="1">
-            <a:spLocks/>
-          </p:cNvSpPr>
-          <p:nvPr/>
-        </p:nvSpPr>
-        <p:spPr>
-          <a:xfrm>
-            <a:off x="838200" y="365125"/>
-            <a:ext cx="10515600" cy="1325563"/>
-          </a:xfrm>
-          <a:prstGeom prst="rect">
-            <a:avLst/>
-          </a:prstGeom>
-        </p:spPr>
-        <p:txBody>
-          <a:bodyPr vert="horz" lIns="91440" tIns="45720" rIns="91440" bIns="45720" rtlCol="0" anchor="ctr">
-            <a:normAutofit/>
-          </a:bodyPr>
-          <a:lstStyle>
-            <a:lvl1pPr algn="l" defTabSz="914400" rtl="0" eaLnBrk="1" latinLnBrk="0" hangingPunct="1">
-              <a:lnSpc>
-                <a:spcPct val="90000"/>
-              </a:lnSpc>
-              <a:spcBef>
-                <a:spcPct val="0"/>
-              </a:spcBef>
-              <a:buNone/>
-              <a:defRPr sz="4400" kern="1200">
-                <a:solidFill>
-                  <a:schemeClr val="tx1"/>
-                </a:solidFill>
-                <a:latin typeface="+mj-lt"/>
-                <a:ea typeface="+mj-ea"/>
-                <a:cs typeface="+mj-cs"/>
-              </a:defRPr>
-            </a:lvl1pPr>
-          </a:lstStyle>
-          <a:p>
-            <a:r>
-              <a:rPr lang="en-US" dirty="0">
-                <a:solidFill>
-                  <a:srgbClr val="C00000"/>
-                </a:solidFill>
-                <a:latin typeface="Cambria" panose="02040503050406030204" pitchFamily="18" charset="0"/>
-                <a:ea typeface="Cambria" panose="02040503050406030204" pitchFamily="18" charset="0"/>
-              </a:rPr>
-              <a:t>What is </a:t>
-            </a:r>
-            <a:r>
-              <a:rPr lang="en-US" dirty="0" err="1">
-                <a:solidFill>
-                  <a:srgbClr val="C00000"/>
-                </a:solidFill>
-                <a:latin typeface="Cambria" panose="02040503050406030204" pitchFamily="18" charset="0"/>
-                <a:ea typeface="Cambria" panose="02040503050406030204" pitchFamily="18" charset="0"/>
-              </a:rPr>
-              <a:t>Compas</a:t>
-            </a:r>
-            <a:endParaRPr lang="en-US" dirty="0">
-              <a:solidFill>
-                <a:srgbClr val="C00000"/>
-              </a:solidFill>
-              <a:latin typeface="Cambria" panose="02040503050406030204" pitchFamily="18" charset="0"/>
-              <a:ea typeface="Cambria" panose="02040503050406030204" pitchFamily="18" charset="0"/>
-            </a:endParaRPr>
-          </a:p>
-        </p:txBody>
-      </p:sp>
-    </p:spTree>
-    <p:extLst>
-      <p:ext uri="{BB962C8B-B14F-4D97-AF65-F5344CB8AC3E}">
-        <p14:creationId xmlns:p14="http://schemas.microsoft.com/office/powerpoint/2010/main" val="1080628939"/>
-      </p:ext>
-    </p:extLst>
-  </p:cSld>
-  <p:clrMapOvr>
-    <a:masterClrMapping/>
-  </p:clrMapOvr>
-  <mc:AlternateContent xmlns:mc="http://schemas.openxmlformats.org/markup-compatibility/2006" xmlns:p159="http://schemas.microsoft.com/office/powerpoint/2015/09/main">
-    <mc:Choice Requires="p159">
-      <p:transition xmlns:p14="http://schemas.microsoft.com/office/powerpoint/2010/main" spd="slow" p14:dur="2000">
-        <p159:morph option="byObject"/>
-      </p:transition>
-    </mc:Choice>
-    <mc:Fallback xmlns="">
-      <p:transition spd="slow">
-        <p:fade/>
-      </p:transition>
-    </mc:Fallback>
-  </mc:AlternateContent>
-</p:sld>
-</file>
-
-<file path=ppt/slides/slide9.xml><?xml version="1.0" encoding="utf-8"?>
-<p:sld xmlns:a="http://schemas.openxmlformats.org/drawingml/2006/main" xmlns:r="http://schemas.openxmlformats.org/officeDocument/2006/relationships" xmlns:p="http://schemas.openxmlformats.org/presentationml/2006/main">
-  <p:cSld>
-    <p:spTree>
-      <p:nvGrpSpPr>
-        <p:cNvPr id="1" name=""/>
-        <p:cNvGrpSpPr/>
-        <p:nvPr/>
-      </p:nvGrpSpPr>
-      <p:grpSpPr>
-        <a:xfrm>
-          <a:off x="0" y="0"/>
-          <a:ext cx="0" cy="0"/>
-          <a:chOff x="0" y="0"/>
-          <a:chExt cx="0" cy="0"/>
-        </a:xfrm>
-      </p:grpSpPr>
-      <p:pic>
-        <p:nvPicPr>
-          <p:cNvPr id="3074" name="Picture 2" descr="https://img.washingtonpost.com/wp-apps/imrs.php?src=https://img.washingtonpost.com/blogs/monkey-cage/files/2016/10/GOEL-Fig-2.png&amp;w=1484">
-            <a:extLst>
-              <a:ext uri="{FF2B5EF4-FFF2-40B4-BE49-F238E27FC236}">
-                <a16:creationId xmlns:a16="http://schemas.microsoft.com/office/drawing/2014/main" id="{63DEE0F3-52C7-4E5F-9239-C48C5D3B9804}"/>
-              </a:ext>
-            </a:extLst>
-          </p:cNvPr>
-          <p:cNvPicPr>
-            <a:picLocks noChangeAspect="1" noChangeArrowheads="1"/>
-          </p:cNvPicPr>
-          <p:nvPr/>
-        </p:nvPicPr>
-        <p:blipFill>
-          <a:blip r:embed="rId2">
-            <a:extLst>
-              <a:ext uri="{28A0092B-C50C-407E-A947-70E740481C1C}">
-                <a14:useLocalDpi xmlns:a14="http://schemas.microsoft.com/office/drawing/2010/main" val="0"/>
-              </a:ext>
-            </a:extLst>
-          </a:blip>
-          <a:srcRect/>
-          <a:stretch>
-            <a:fillRect/>
-          </a:stretch>
-        </p:blipFill>
-        <p:spPr bwMode="auto">
-          <a:xfrm>
-            <a:off x="401870" y="971550"/>
-            <a:ext cx="11790130" cy="5234941"/>
-          </a:xfrm>
-          <a:prstGeom prst="rect">
-            <a:avLst/>
-          </a:prstGeom>
-          <a:noFill/>
-          <a:extLst>
-            <a:ext uri="{909E8E84-426E-40DD-AFC4-6F175D3DCCD1}">
-              <a14:hiddenFill xmlns:a14="http://schemas.microsoft.com/office/drawing/2010/main">
-                <a:solidFill>
-                  <a:srgbClr val="FFFFFF"/>
-                </a:solidFill>
-              </a14:hiddenFill>
-            </a:ext>
-          </a:extLst>
-        </p:spPr>
-      </p:pic>
-      <p:sp>
-        <p:nvSpPr>
-          <p:cNvPr id="4" name="Rectangle 3">
-            <a:extLst>
-              <a:ext uri="{FF2B5EF4-FFF2-40B4-BE49-F238E27FC236}">
-                <a16:creationId xmlns:a16="http://schemas.microsoft.com/office/drawing/2014/main" id="{31B7BDFC-8663-47CF-A8F2-C531D3609B8B}"/>
-              </a:ext>
-            </a:extLst>
-          </p:cNvPr>
-          <p:cNvSpPr/>
-          <p:nvPr/>
-        </p:nvSpPr>
-        <p:spPr>
-          <a:xfrm>
-            <a:off x="1736244" y="3753134"/>
-            <a:ext cx="1680951" cy="1752316"/>
-          </a:xfrm>
-          <a:prstGeom prst="rect">
-            <a:avLst/>
-          </a:prstGeom>
-          <a:solidFill>
-            <a:srgbClr val="92D050"/>
-          </a:solidFill>
-          <a:ln>
-            <a:noFill/>
-          </a:ln>
-        </p:spPr>
-        <p:style>
-          <a:lnRef idx="2">
-            <a:schemeClr val="accent1">
-              <a:shade val="50000"/>
-            </a:schemeClr>
-          </a:lnRef>
-          <a:fillRef idx="1">
-            <a:schemeClr val="accent1"/>
-          </a:fillRef>
-          <a:effectRef idx="0">
-            <a:schemeClr val="accent1"/>
-          </a:effectRef>
-          <a:fontRef idx="minor">
-            <a:schemeClr val="lt1"/>
-          </a:fontRef>
-        </p:style>
-        <p:txBody>
-          <a:bodyPr rtlCol="0" anchor="ctr"/>
-          <a:lstStyle/>
-          <a:p>
-            <a:pPr marL="0" marR="0" lvl="0" indent="0" algn="ctr" defTabSz="914400" rtl="0" eaLnBrk="1" fontAlgn="auto" latinLnBrk="0" hangingPunct="1">
-              <a:lnSpc>
-                <a:spcPct val="100000"/>
-              </a:lnSpc>
-              <a:spcBef>
-                <a:spcPts val="0"/>
-              </a:spcBef>
-              <a:spcAft>
-                <a:spcPts val="0"/>
-              </a:spcAft>
-              <a:buClrTx/>
-              <a:buSzTx/>
-              <a:buFontTx/>
-              <a:buNone/>
-              <a:tabLst/>
-              <a:defRPr/>
-            </a:pPr>
-            <a:endParaRPr kumimoji="0" lang="en-US" sz="1800" b="0" i="0" u="none" strike="noStrike" kern="1200" cap="none" spc="0" normalizeH="0" baseline="0" noProof="0">
-              <a:ln>
-                <a:noFill/>
-              </a:ln>
-              <a:solidFill>
-                <a:prstClr val="white"/>
-              </a:solidFill>
-              <a:effectLst/>
-              <a:uLnTx/>
-              <a:uFillTx/>
-              <a:latin typeface="Calibri" panose="020F0502020204030204"/>
-              <a:ea typeface="+mn-ea"/>
-              <a:cs typeface="+mn-cs"/>
-            </a:endParaRPr>
-          </a:p>
-        </p:txBody>
-      </p:sp>
-      <p:sp>
-        <p:nvSpPr>
-          <p:cNvPr id="6" name="Rectangle 5">
-            <a:extLst>
-              <a:ext uri="{FF2B5EF4-FFF2-40B4-BE49-F238E27FC236}">
-                <a16:creationId xmlns:a16="http://schemas.microsoft.com/office/drawing/2014/main" id="{438224BE-F3E2-4670-85AF-AD28D83F4C79}"/>
-              </a:ext>
-            </a:extLst>
-          </p:cNvPr>
-          <p:cNvSpPr/>
-          <p:nvPr/>
-        </p:nvSpPr>
-        <p:spPr>
-          <a:xfrm>
-            <a:off x="3613597" y="4217158"/>
-            <a:ext cx="1678675" cy="1288292"/>
-          </a:xfrm>
-          <a:prstGeom prst="rect">
-            <a:avLst/>
-          </a:prstGeom>
-          <a:solidFill>
-            <a:srgbClr val="FF0000"/>
-          </a:solidFill>
-          <a:ln>
-            <a:noFill/>
-          </a:ln>
-        </p:spPr>
-        <p:style>
-          <a:lnRef idx="2">
-            <a:schemeClr val="accent1">
-              <a:shade val="50000"/>
-            </a:schemeClr>
-          </a:lnRef>
-          <a:fillRef idx="1">
-            <a:schemeClr val="accent1"/>
-          </a:fillRef>
-          <a:effectRef idx="0">
-            <a:schemeClr val="accent1"/>
-          </a:effectRef>
-          <a:fontRef idx="minor">
-            <a:schemeClr val="lt1"/>
-          </a:fontRef>
-        </p:style>
-        <p:txBody>
-          <a:bodyPr rtlCol="0" anchor="ctr"/>
-          <a:lstStyle/>
-          <a:p>
-            <a:pPr marL="0" marR="0" lvl="0" indent="0" algn="ctr" defTabSz="914400" rtl="0" eaLnBrk="1" fontAlgn="auto" latinLnBrk="0" hangingPunct="1">
-              <a:lnSpc>
-                <a:spcPct val="100000"/>
-              </a:lnSpc>
-              <a:spcBef>
-                <a:spcPts val="0"/>
-              </a:spcBef>
-              <a:spcAft>
-                <a:spcPts val="0"/>
-              </a:spcAft>
-              <a:buClrTx/>
-              <a:buSzTx/>
-              <a:buFontTx/>
-              <a:buNone/>
-              <a:tabLst/>
-              <a:defRPr/>
-            </a:pPr>
-            <a:endParaRPr kumimoji="0" lang="en-US" sz="1800" b="0" i="0" u="none" strike="noStrike" kern="1200" cap="none" spc="0" normalizeH="0" baseline="0" noProof="0">
-              <a:ln>
-                <a:noFill/>
-              </a:ln>
-              <a:solidFill>
-                <a:prstClr val="white"/>
-              </a:solidFill>
-              <a:effectLst/>
-              <a:uLnTx/>
-              <a:uFillTx/>
-              <a:latin typeface="Calibri" panose="020F0502020204030204"/>
-              <a:ea typeface="+mn-ea"/>
-              <a:cs typeface="+mn-cs"/>
-            </a:endParaRPr>
-          </a:p>
-        </p:txBody>
-      </p:sp>
-      <p:sp>
-        <p:nvSpPr>
-          <p:cNvPr id="7" name="Rectangle 6">
-            <a:extLst>
-              <a:ext uri="{FF2B5EF4-FFF2-40B4-BE49-F238E27FC236}">
-                <a16:creationId xmlns:a16="http://schemas.microsoft.com/office/drawing/2014/main" id="{D65B0B0B-092C-4B65-89B6-B984D62000AC}"/>
-              </a:ext>
-            </a:extLst>
-          </p:cNvPr>
-          <p:cNvSpPr/>
-          <p:nvPr/>
-        </p:nvSpPr>
-        <p:spPr>
-          <a:xfrm>
-            <a:off x="6005719" y="3493827"/>
-            <a:ext cx="1680950" cy="2011623"/>
-          </a:xfrm>
-          <a:prstGeom prst="rect">
-            <a:avLst/>
-          </a:prstGeom>
-          <a:solidFill>
-            <a:srgbClr val="92D050"/>
-          </a:solidFill>
-          <a:ln>
-            <a:noFill/>
-          </a:ln>
-        </p:spPr>
-        <p:style>
-          <a:lnRef idx="2">
-            <a:schemeClr val="accent1">
-              <a:shade val="50000"/>
-            </a:schemeClr>
-          </a:lnRef>
-          <a:fillRef idx="1">
-            <a:schemeClr val="accent1"/>
-          </a:fillRef>
-          <a:effectRef idx="0">
-            <a:schemeClr val="accent1"/>
-          </a:effectRef>
-          <a:fontRef idx="minor">
-            <a:schemeClr val="lt1"/>
-          </a:fontRef>
-        </p:style>
-        <p:txBody>
-          <a:bodyPr rtlCol="0" anchor="ctr"/>
-          <a:lstStyle/>
-          <a:p>
-            <a:pPr marL="0" marR="0" lvl="0" indent="0" algn="ctr" defTabSz="914400" rtl="0" eaLnBrk="1" fontAlgn="auto" latinLnBrk="0" hangingPunct="1">
-              <a:lnSpc>
-                <a:spcPct val="100000"/>
-              </a:lnSpc>
-              <a:spcBef>
-                <a:spcPts val="0"/>
-              </a:spcBef>
-              <a:spcAft>
-                <a:spcPts val="0"/>
-              </a:spcAft>
-              <a:buClrTx/>
-              <a:buSzTx/>
-              <a:buFontTx/>
-              <a:buNone/>
-              <a:tabLst/>
-              <a:defRPr/>
-            </a:pPr>
-            <a:endParaRPr kumimoji="0" lang="en-US" sz="1800" b="0" i="0" u="none" strike="noStrike" kern="1200" cap="none" spc="0" normalizeH="0" baseline="0" noProof="0">
-              <a:ln>
-                <a:noFill/>
-              </a:ln>
-              <a:solidFill>
-                <a:prstClr val="white"/>
-              </a:solidFill>
-              <a:effectLst/>
-              <a:uLnTx/>
-              <a:uFillTx/>
-              <a:latin typeface="Calibri" panose="020F0502020204030204"/>
-              <a:ea typeface="+mn-ea"/>
-              <a:cs typeface="+mn-cs"/>
-            </a:endParaRPr>
-          </a:p>
-        </p:txBody>
-      </p:sp>
-      <p:sp>
-        <p:nvSpPr>
-          <p:cNvPr id="8" name="Rectangle 7">
-            <a:extLst>
-              <a:ext uri="{FF2B5EF4-FFF2-40B4-BE49-F238E27FC236}">
-                <a16:creationId xmlns:a16="http://schemas.microsoft.com/office/drawing/2014/main" id="{A3A50C45-E46F-4CFD-AAC9-4107EF23F05C}"/>
-              </a:ext>
-            </a:extLst>
-          </p:cNvPr>
-          <p:cNvSpPr/>
-          <p:nvPr/>
-        </p:nvSpPr>
-        <p:spPr>
-          <a:xfrm>
-            <a:off x="7883071" y="4940490"/>
-            <a:ext cx="1678675" cy="564960"/>
-          </a:xfrm>
-          <a:prstGeom prst="rect">
-            <a:avLst/>
-          </a:prstGeom>
-          <a:solidFill>
-            <a:srgbClr val="FF0000"/>
-          </a:solidFill>
-          <a:ln>
-            <a:noFill/>
-          </a:ln>
-        </p:spPr>
-        <p:style>
-          <a:lnRef idx="2">
-            <a:schemeClr val="accent1">
-              <a:shade val="50000"/>
-            </a:schemeClr>
-          </a:lnRef>
-          <a:fillRef idx="1">
-            <a:schemeClr val="accent1"/>
-          </a:fillRef>
-          <a:effectRef idx="0">
-            <a:schemeClr val="accent1"/>
-          </a:effectRef>
-          <a:fontRef idx="minor">
-            <a:schemeClr val="lt1"/>
-          </a:fontRef>
-        </p:style>
-        <p:txBody>
-          <a:bodyPr rtlCol="0" anchor="ctr"/>
-          <a:lstStyle/>
-          <a:p>
-            <a:pPr marL="0" marR="0" lvl="0" indent="0" algn="ctr" defTabSz="914400" rtl="0" eaLnBrk="1" fontAlgn="auto" latinLnBrk="0" hangingPunct="1">
-              <a:lnSpc>
-                <a:spcPct val="100000"/>
-              </a:lnSpc>
-              <a:spcBef>
-                <a:spcPts val="0"/>
-              </a:spcBef>
-              <a:spcAft>
-                <a:spcPts val="0"/>
-              </a:spcAft>
-              <a:buClrTx/>
-              <a:buSzTx/>
-              <a:buFontTx/>
-              <a:buNone/>
-              <a:tabLst/>
-              <a:defRPr/>
-            </a:pPr>
-            <a:endParaRPr kumimoji="0" lang="en-US" sz="1800" b="0" i="0" u="none" strike="noStrike" kern="1200" cap="none" spc="0" normalizeH="0" baseline="0" noProof="0">
-              <a:ln>
-                <a:noFill/>
-              </a:ln>
-              <a:solidFill>
-                <a:prstClr val="white"/>
-              </a:solidFill>
-              <a:effectLst/>
-              <a:uLnTx/>
-              <a:uFillTx/>
-              <a:latin typeface="Calibri" panose="020F0502020204030204"/>
-              <a:ea typeface="+mn-ea"/>
-              <a:cs typeface="+mn-cs"/>
-            </a:endParaRPr>
-          </a:p>
-        </p:txBody>
-      </p:sp>
-      <p:pic>
-        <p:nvPicPr>
-          <p:cNvPr id="11" name="Picture 10">
-            <a:extLst>
-              <a:ext uri="{FF2B5EF4-FFF2-40B4-BE49-F238E27FC236}">
-                <a16:creationId xmlns:a16="http://schemas.microsoft.com/office/drawing/2014/main" id="{4C1B9E04-D6FA-464C-BC9A-CB369197D65D}"/>
-              </a:ext>
-            </a:extLst>
-          </p:cNvPr>
-          <p:cNvPicPr>
-            <a:picLocks noChangeAspect="1"/>
-          </p:cNvPicPr>
-          <p:nvPr/>
-        </p:nvPicPr>
-        <p:blipFill>
-          <a:blip r:embed="rId3"/>
-          <a:stretch>
-            <a:fillRect/>
-          </a:stretch>
-        </p:blipFill>
-        <p:spPr>
-          <a:xfrm>
-            <a:off x="5053566" y="695628"/>
-            <a:ext cx="1871054" cy="275922"/>
-          </a:xfrm>
-          <a:prstGeom prst="rect">
-            <a:avLst/>
-          </a:prstGeom>
-        </p:spPr>
-      </p:pic>
-    </p:spTree>
-    <p:extLst>
-      <p:ext uri="{BB962C8B-B14F-4D97-AF65-F5344CB8AC3E}">
-        <p14:creationId xmlns:p14="http://schemas.microsoft.com/office/powerpoint/2010/main" val="3069737939"/>
       </p:ext>
     </p:extLst>
   </p:cSld>

</xml_diff>